<commit_message>
Informe y presentacion con la interfaz web
- Seccion 7.4 del informe con capturas de la interfaz publicada en Render
- Interfaz agregada a arquitectura, documentacion, productos y anexos
- Diapositiva de la interfaz web en la presentacion
</commit_message>
<xml_diff>
--- a/docs/PRESENTACION_CHD_RENTAL_PRO_DSWII_Grupo10.pptx
+++ b/docs/PRESENTACION_CHD_RENTAL_PRO_DSWII_Grupo10.pptx
@@ -20,9 +20,10 @@
     <p:sldId id="268" r:id="rId14"/>
     <p:sldId id="269" r:id="rId15"/>
     <p:sldId id="270" r:id="rId16"/>
+    <p:sldId id="271" r:id="rId17"/>
   </p:sldIdLst>
   <p:notesMasterIdLst>
-    <p:notesMasterId r:id="rId17"/>
+    <p:notesMasterId r:id="rId18"/>
   </p:notesMasterIdLst>
   <p:sldSz cx="12192000" cy="6858000"/>
   <p:notesSz cx="6858000" cy="12192000"/>
@@ -692,7 +693,7 @@
           <a:p>
             <a:r>
               <a:rPr lang="en-US" dirty="0"/>
-              <a:t/>
+              <a:t>Mostrar en vivo: login en la URL de Render, panel de inicio y registro de un contrato con la vista previa del IGV.</a:t>
             </a:r>
             <a:endParaRPr lang="en-US" dirty="0"/>
           </a:p>
@@ -1068,6 +1069,94 @@
             <a:fld id="{F7021451-1387-4CA6-816F-3879F97B5CBC}" type="slidenum">
               <a:rPr lang="en-US"/>
               <a:t>15</a:t>
+            </a:fld>
+            <a:endParaRPr lang="en-US"/>
+          </a:p>
+        </p:txBody>
+      </p:sp>
+    </p:spTree>
+    <p:extLst>
+      <p:ext uri="{BB962C8B-B14F-4D97-AF65-F5344CB8AC3E}">
+        <p14:creationId xmlns:p14="http://schemas.microsoft.com/office/powerpoint/2010/main" val="1024086991"/>
+      </p:ext>
+    </p:extLst>
+  </p:cSld>
+  <p:clrMapOvr>
+    <a:masterClrMapping/>
+  </p:clrMapOvr>
+</p:notes>
+</file>
+
+<file path=ppt/notesSlides/notesSlide16.xml><?xml version="1.0" encoding="utf-8"?>
+<p:notes xmlns:a="http://schemas.openxmlformats.org/drawingml/2006/main" xmlns:r="http://schemas.openxmlformats.org/officeDocument/2006/relationships" xmlns:p="http://schemas.openxmlformats.org/presentationml/2006/main">
+  <p:cSld>
+    <p:spTree>
+      <p:nvGrpSpPr>
+        <p:cNvPr id="1" name=""/>
+        <p:cNvGrpSpPr/>
+        <p:nvPr/>
+      </p:nvGrpSpPr>
+      <p:grpSpPr>
+        <a:xfrm>
+          <a:off x="0" y="0"/>
+          <a:ext cx="0" cy="0"/>
+          <a:chOff x="0" y="0"/>
+          <a:chExt cx="0" cy="0"/>
+        </a:xfrm>
+      </p:grpSpPr>
+      <p:sp>
+        <p:nvSpPr>
+          <p:cNvPr id="2" name="Slide Image Placeholder 1"/>
+          <p:cNvSpPr>
+            <a:spLocks noGrp="1" noRot="1" noChangeAspect="1"/>
+          </p:cNvSpPr>
+          <p:nvPr>
+            <p:ph type="sldImg"/>
+          </p:nvPr>
+        </p:nvSpPr>
+        <p:spPr/>
+      </p:sp>
+      <p:sp>
+        <p:nvSpPr>
+          <p:cNvPr id="3" name="Notes Placeholder 2"/>
+          <p:cNvSpPr>
+            <a:spLocks noGrp="1"/>
+          </p:cNvSpPr>
+          <p:nvPr>
+            <p:ph type="body" idx="1"/>
+          </p:nvPr>
+        </p:nvSpPr>
+        <p:spPr/>
+        <p:txBody>
+          <a:bodyPr/>
+          <a:lstStyle/>
+          <a:p>
+            <a:r>
+              <a:rPr lang="en-US" dirty="0"/>
+              <a:t/>
+            </a:r>
+            <a:endParaRPr lang="en-US" dirty="0"/>
+          </a:p>
+        </p:txBody>
+      </p:sp>
+      <p:sp>
+        <p:nvSpPr>
+          <p:cNvPr id="4" name="Slide Number Placeholder 3"/>
+          <p:cNvSpPr>
+            <a:spLocks noGrp="1"/>
+          </p:cNvSpPr>
+          <p:nvPr>
+            <p:ph type="sldNum" sz="quarter" idx="10"/>
+          </p:nvPr>
+        </p:nvSpPr>
+        <p:spPr/>
+        <p:txBody>
+          <a:bodyPr/>
+          <a:lstStyle/>
+          <a:p>
+            <a:fld id="{F7021451-1387-4CA6-816F-3879F97B5CBC}" type="slidenum">
+              <a:rPr lang="en-US"/>
+              <a:t>16</a:t>
             </a:fld>
             <a:endParaRPr lang="en-US"/>
           </a:p>
@@ -2847,7 +2936,7 @@
                 <a:ea typeface="Arial" pitchFamily="34" charset="-122"/>
                 <a:cs typeface="Arial" pitchFamily="34" charset="-120"/>
               </a:rPr>
-              <a:t>Evidencia: colección Postman en la nube</a:t>
+              <a:t>Interfaz web en la misma URL</a:t>
             </a:r>
             <a:endParaRPr lang="en-US" sz="3200" dirty="0"/>
           </a:p>
@@ -2886,7 +2975,7 @@
                 <a:ea typeface="Arial" pitchFamily="34" charset="-122"/>
                 <a:cs typeface="Arial" pitchFamily="34" charset="-120"/>
               </a:rPr>
-              <a:t>Ejecutada con Newman contra la URL de Render</a:t>
+              <a:t>Consume los mismos servicios REST: login, panel y gestión de los seis recursos</a:t>
             </a:r>
             <a:endParaRPr lang="en-US" sz="1600" dirty="0"/>
           </a:p>
@@ -2894,322 +2983,134 @@
       </p:sp>
       <p:sp>
         <p:nvSpPr>
-          <p:cNvPr id="4" name="Shape 2"/>
-          <p:cNvSpPr/>
+          <p:cNvPr id="4" name="Text 2"/>
+          <p:cNvSpPr txBox="1"/>
           <p:nvPr/>
         </p:nvSpPr>
         <p:spPr>
           <a:xfrm>
             <a:off x="548640" y="1783080"/>
-            <a:ext cx="2926080" cy="1280160"/>
-          </a:xfrm>
-          <a:prstGeom prst="roundRect">
-            <a:avLst>
-              <a:gd name="adj" fmla="val 8571"/>
-            </a:avLst>
-          </a:prstGeom>
-          <a:solidFill>
-            <a:srgbClr val="F2F4F7"/>
-          </a:solidFill>
-          <a:ln w="12700">
-            <a:solidFill>
-              <a:srgbClr val="F2F4F7"/>
-            </a:solidFill>
-            <a:prstDash val="solid"/>
-          </a:ln>
-        </p:spPr>
-      </p:sp>
-      <p:sp>
-        <p:nvSpPr>
-          <p:cNvPr id="5" name="Text 3"/>
-          <p:cNvSpPr txBox="1"/>
-          <p:nvPr/>
-        </p:nvSpPr>
-        <p:spPr>
-          <a:xfrm>
-            <a:off x="731520" y="1874520"/>
-            <a:ext cx="2560320" cy="777240"/>
-          </a:xfrm>
-          <a:prstGeom prst="rect">
-            <a:avLst/>
-          </a:prstGeom>
-          <a:noFill/>
-          <a:ln/>
-        </p:spPr>
-        <p:txBody>
-          <a:bodyPr wrap="square" lIns="0" tIns="0" rIns="0" bIns="0" rtlCol="0" anchor="ctr"/>
-          <a:lstStyle/>
-          <a:p>
-            <a:pPr indent="0" marL="0">
-              <a:buNone/>
-            </a:pPr>
-            <a:r>
-              <a:rPr lang="en-US" sz="4400" b="1" dirty="0">
-                <a:solidFill>
-                  <a:srgbClr val="0B3D91"/>
-                </a:solidFill>
-                <a:latin typeface="Arial" pitchFamily="34" charset="0"/>
-                <a:ea typeface="Arial" pitchFamily="34" charset="-122"/>
-                <a:cs typeface="Arial" pitchFamily="34" charset="-120"/>
-              </a:rPr>
-              <a:t>35</a:t>
-            </a:r>
-            <a:endParaRPr lang="en-US" sz="4400" dirty="0"/>
-          </a:p>
-        </p:txBody>
-      </p:sp>
-      <p:sp>
-        <p:nvSpPr>
-          <p:cNvPr id="6" name="Text 4"/>
-          <p:cNvSpPr txBox="1"/>
-          <p:nvPr/>
-        </p:nvSpPr>
-        <p:spPr>
-          <a:xfrm>
-            <a:off x="731520" y="2606040"/>
-            <a:ext cx="2560320" cy="365760"/>
-          </a:xfrm>
-          <a:prstGeom prst="rect">
-            <a:avLst/>
-          </a:prstGeom>
-          <a:noFill/>
-          <a:ln/>
-        </p:spPr>
-        <p:txBody>
-          <a:bodyPr wrap="square" lIns="0" tIns="0" rIns="0" bIns="0" rtlCol="0" anchor="ctr"/>
-          <a:lstStyle/>
-          <a:p>
-            <a:pPr indent="0" marL="0">
-              <a:buNone/>
-            </a:pPr>
-            <a:r>
-              <a:rPr lang="en-US" sz="1500" dirty="0">
-                <a:solidFill>
-                  <a:srgbClr val="5D6D7E"/>
-                </a:solidFill>
-                <a:latin typeface="Arial" pitchFamily="34" charset="0"/>
-                <a:ea typeface="Arial" pitchFamily="34" charset="-122"/>
-                <a:cs typeface="Arial" pitchFamily="34" charset="-120"/>
-              </a:rPr>
-              <a:t>solicitudes</a:t>
-            </a:r>
-            <a:endParaRPr lang="en-US" sz="1500" dirty="0"/>
-          </a:p>
-        </p:txBody>
-      </p:sp>
-      <p:sp>
-        <p:nvSpPr>
-          <p:cNvPr id="7" name="Shape 5"/>
-          <p:cNvSpPr/>
-          <p:nvPr/>
-        </p:nvSpPr>
-        <p:spPr>
-          <a:xfrm>
-            <a:off x="548640" y="3246120"/>
-            <a:ext cx="2926080" cy="1280160"/>
-          </a:xfrm>
-          <a:prstGeom prst="roundRect">
-            <a:avLst>
-              <a:gd name="adj" fmla="val 8571"/>
-            </a:avLst>
-          </a:prstGeom>
-          <a:solidFill>
-            <a:srgbClr val="F2F4F7"/>
-          </a:solidFill>
-          <a:ln w="12700">
-            <a:solidFill>
-              <a:srgbClr val="F2F4F7"/>
-            </a:solidFill>
-            <a:prstDash val="solid"/>
-          </a:ln>
-        </p:spPr>
-      </p:sp>
-      <p:sp>
-        <p:nvSpPr>
-          <p:cNvPr id="8" name="Text 6"/>
-          <p:cNvSpPr txBox="1"/>
-          <p:nvPr/>
-        </p:nvSpPr>
-        <p:spPr>
-          <a:xfrm>
-            <a:off x="731520" y="3337560"/>
-            <a:ext cx="2560320" cy="777240"/>
-          </a:xfrm>
-          <a:prstGeom prst="rect">
-            <a:avLst/>
-          </a:prstGeom>
-          <a:noFill/>
-          <a:ln/>
-        </p:spPr>
-        <p:txBody>
-          <a:bodyPr wrap="square" lIns="0" tIns="0" rIns="0" bIns="0" rtlCol="0" anchor="ctr"/>
-          <a:lstStyle/>
-          <a:p>
-            <a:pPr indent="0" marL="0">
-              <a:buNone/>
-            </a:pPr>
-            <a:r>
-              <a:rPr lang="en-US" sz="4400" b="1" dirty="0">
-                <a:solidFill>
-                  <a:srgbClr val="0B3D91"/>
-                </a:solidFill>
-                <a:latin typeface="Arial" pitchFamily="34" charset="0"/>
-                <a:ea typeface="Arial" pitchFamily="34" charset="-122"/>
-                <a:cs typeface="Arial" pitchFamily="34" charset="-120"/>
-              </a:rPr>
-              <a:t>39</a:t>
-            </a:r>
-            <a:endParaRPr lang="en-US" sz="4400" dirty="0"/>
-          </a:p>
-        </p:txBody>
-      </p:sp>
-      <p:sp>
-        <p:nvSpPr>
-          <p:cNvPr id="9" name="Text 7"/>
-          <p:cNvSpPr txBox="1"/>
-          <p:nvPr/>
-        </p:nvSpPr>
-        <p:spPr>
-          <a:xfrm>
-            <a:off x="731520" y="4069080"/>
-            <a:ext cx="2560320" cy="365760"/>
-          </a:xfrm>
-          <a:prstGeom prst="rect">
-            <a:avLst/>
-          </a:prstGeom>
-          <a:noFill/>
-          <a:ln/>
-        </p:spPr>
-        <p:txBody>
-          <a:bodyPr wrap="square" lIns="0" tIns="0" rIns="0" bIns="0" rtlCol="0" anchor="ctr"/>
-          <a:lstStyle/>
-          <a:p>
-            <a:pPr indent="0" marL="0">
-              <a:buNone/>
-            </a:pPr>
-            <a:r>
-              <a:rPr lang="en-US" sz="1500" dirty="0">
-                <a:solidFill>
-                  <a:srgbClr val="5D6D7E"/>
-                </a:solidFill>
-                <a:latin typeface="Arial" pitchFamily="34" charset="0"/>
-                <a:ea typeface="Arial" pitchFamily="34" charset="-122"/>
-                <a:cs typeface="Arial" pitchFamily="34" charset="-120"/>
-              </a:rPr>
-              <a:t>validaciones</a:t>
-            </a:r>
-            <a:endParaRPr lang="en-US" sz="1500" dirty="0"/>
-          </a:p>
-        </p:txBody>
-      </p:sp>
-      <p:sp>
-        <p:nvSpPr>
-          <p:cNvPr id="10" name="Shape 8"/>
-          <p:cNvSpPr/>
-          <p:nvPr/>
-        </p:nvSpPr>
-        <p:spPr>
-          <a:xfrm>
-            <a:off x="548640" y="4709160"/>
-            <a:ext cx="2926080" cy="1280160"/>
-          </a:xfrm>
-          <a:prstGeom prst="roundRect">
-            <a:avLst>
-              <a:gd name="adj" fmla="val 8571"/>
-            </a:avLst>
-          </a:prstGeom>
-          <a:solidFill>
-            <a:srgbClr val="E3F4EA"/>
-          </a:solidFill>
-          <a:ln w="12700">
-            <a:solidFill>
-              <a:srgbClr val="E3F4EA"/>
-            </a:solidFill>
-            <a:prstDash val="solid"/>
-          </a:ln>
-        </p:spPr>
-      </p:sp>
-      <p:sp>
-        <p:nvSpPr>
-          <p:cNvPr id="11" name="Text 9"/>
-          <p:cNvSpPr txBox="1"/>
-          <p:nvPr/>
-        </p:nvSpPr>
-        <p:spPr>
-          <a:xfrm>
-            <a:off x="731520" y="4800600"/>
-            <a:ext cx="2560320" cy="777240"/>
-          </a:xfrm>
-          <a:prstGeom prst="rect">
-            <a:avLst/>
-          </a:prstGeom>
-          <a:noFill/>
-          <a:ln/>
-        </p:spPr>
-        <p:txBody>
-          <a:bodyPr wrap="square" lIns="0" tIns="0" rIns="0" bIns="0" rtlCol="0" anchor="ctr"/>
-          <a:lstStyle/>
-          <a:p>
-            <a:pPr indent="0" marL="0">
-              <a:buNone/>
-            </a:pPr>
-            <a:r>
-              <a:rPr lang="en-US" sz="4400" b="1" dirty="0">
-                <a:solidFill>
-                  <a:srgbClr val="11763A"/>
-                </a:solidFill>
-                <a:latin typeface="Arial" pitchFamily="34" charset="0"/>
-                <a:ea typeface="Arial" pitchFamily="34" charset="-122"/>
-                <a:cs typeface="Arial" pitchFamily="34" charset="-120"/>
-              </a:rPr>
-              <a:t>0</a:t>
-            </a:r>
-            <a:endParaRPr lang="en-US" sz="4400" dirty="0"/>
-          </a:p>
-        </p:txBody>
-      </p:sp>
-      <p:sp>
-        <p:nvSpPr>
-          <p:cNvPr id="12" name="Text 10"/>
-          <p:cNvSpPr txBox="1"/>
-          <p:nvPr/>
-        </p:nvSpPr>
-        <p:spPr>
-          <a:xfrm>
-            <a:off x="731520" y="5532120"/>
-            <a:ext cx="2560320" cy="365760"/>
-          </a:xfrm>
-          <a:prstGeom prst="rect">
-            <a:avLst/>
-          </a:prstGeom>
-          <a:noFill/>
-          <a:ln/>
-        </p:spPr>
-        <p:txBody>
-          <a:bodyPr wrap="square" lIns="0" tIns="0" rIns="0" bIns="0" rtlCol="0" anchor="ctr"/>
-          <a:lstStyle/>
-          <a:p>
-            <a:pPr indent="0" marL="0">
-              <a:buNone/>
-            </a:pPr>
-            <a:r>
-              <a:rPr lang="en-US" sz="1500" dirty="0">
-                <a:solidFill>
-                  <a:srgbClr val="5D6D7E"/>
-                </a:solidFill>
-                <a:latin typeface="Arial" pitchFamily="34" charset="0"/>
-                <a:ea typeface="Arial" pitchFamily="34" charset="-122"/>
-                <a:cs typeface="Arial" pitchFamily="34" charset="-120"/>
-              </a:rPr>
-              <a:t>fallas</a:t>
-            </a:r>
-            <a:endParaRPr lang="en-US" sz="1500" dirty="0"/>
+            <a:ext cx="3931920" cy="4206240"/>
+          </a:xfrm>
+          <a:prstGeom prst="rect">
+            <a:avLst/>
+          </a:prstGeom>
+          <a:noFill/>
+          <a:ln/>
+        </p:spPr>
+        <p:txBody>
+          <a:bodyPr wrap="square" lIns="0" tIns="0" rIns="0" bIns="0" rtlCol="0" anchor="t"/>
+          <a:lstStyle/>
+          <a:p>
+            <a:pPr marL="342900" indent="-342900">
+              <a:spcAft>
+                <a:spcPts val="1200"/>
+              </a:spcAft>
+              <a:buSzPct val="100000"/>
+              <a:buChar char="•"/>
+            </a:pPr>
+            <a:r>
+              <a:rPr lang="en-US" sz="1600" dirty="0">
+                <a:solidFill>
+                  <a:srgbClr val="1B2631"/>
+                </a:solidFill>
+                <a:latin typeface="Arial" pitchFamily="34" charset="0"/>
+                <a:ea typeface="Arial" pitchFamily="34" charset="-122"/>
+                <a:cs typeface="Arial" pitchFamily="34" charset="-120"/>
+              </a:rPr>
+              <a:t>Login con JWT y aviso si el servidor está despertando</a:t>
+            </a:r>
+            <a:endParaRPr lang="en-US" sz="1600" dirty="0"/>
+          </a:p>
+          <a:p>
+            <a:pPr marL="342900" indent="-342900">
+              <a:spcAft>
+                <a:spcPts val="1200"/>
+              </a:spcAft>
+              <a:buSzPct val="100000"/>
+              <a:buChar char="•"/>
+            </a:pPr>
+            <a:r>
+              <a:rPr lang="en-US" sz="1600" dirty="0">
+                <a:solidFill>
+                  <a:srgbClr val="1B2631"/>
+                </a:solidFill>
+                <a:latin typeface="Arial" pitchFamily="34" charset="0"/>
+                <a:ea typeface="Arial" pitchFamily="34" charset="-122"/>
+                <a:cs typeface="Arial" pitchFamily="34" charset="-120"/>
+              </a:rPr>
+              <a:t>Panel con indicadores de la flota y alertas de SOAT</a:t>
+            </a:r>
+            <a:endParaRPr lang="en-US" sz="1600" dirty="0"/>
+          </a:p>
+          <a:p>
+            <a:pPr marL="342900" indent="-342900">
+              <a:spcAft>
+                <a:spcPts val="1200"/>
+              </a:spcAft>
+              <a:buSzPct val="100000"/>
+              <a:buChar char="•"/>
+            </a:pPr>
+            <a:r>
+              <a:rPr lang="en-US" sz="1600" dirty="0">
+                <a:solidFill>
+                  <a:srgbClr val="1B2631"/>
+                </a:solidFill>
+                <a:latin typeface="Arial" pitchFamily="34" charset="0"/>
+                <a:ea typeface="Arial" pitchFamily="34" charset="-122"/>
+                <a:cs typeface="Arial" pitchFamily="34" charset="-120"/>
+              </a:rPr>
+              <a:t>Registrar, editar y eliminar desde formularios</a:t>
+            </a:r>
+            <a:endParaRPr lang="en-US" sz="1600" dirty="0"/>
+          </a:p>
+          <a:p>
+            <a:pPr marL="342900" indent="-342900">
+              <a:spcAft>
+                <a:spcPts val="1200"/>
+              </a:spcAft>
+              <a:buSzPct val="100000"/>
+              <a:buChar char="•"/>
+            </a:pPr>
+            <a:r>
+              <a:rPr lang="en-US" sz="1600" dirty="0">
+                <a:solidFill>
+                  <a:srgbClr val="1B2631"/>
+                </a:solidFill>
+                <a:latin typeface="Arial" pitchFamily="34" charset="0"/>
+                <a:ea typeface="Arial" pitchFamily="34" charset="-122"/>
+                <a:cs typeface="Arial" pitchFamily="34" charset="-120"/>
+              </a:rPr>
+              <a:t>Vista previa del IGV al crear contratos</a:t>
+            </a:r>
+            <a:endParaRPr lang="en-US" sz="1600" dirty="0"/>
+          </a:p>
+          <a:p>
+            <a:pPr marL="342900" indent="-342900">
+              <a:spcAft>
+                <a:spcPts val="1200"/>
+              </a:spcAft>
+              <a:buSzPct val="100000"/>
+              <a:buChar char="•"/>
+            </a:pPr>
+            <a:r>
+              <a:rPr lang="en-US" sz="1600" dirty="0">
+                <a:solidFill>
+                  <a:srgbClr val="1B2631"/>
+                </a:solidFill>
+                <a:latin typeface="Arial" pitchFamily="34" charset="0"/>
+                <a:ea typeface="Arial" pitchFamily="34" charset="-122"/>
+                <a:cs typeface="Arial" pitchFamily="34" charset="-120"/>
+              </a:rPr>
+              <a:t>Opciones según el rol y modo oscuro</a:t>
+            </a:r>
+            <a:endParaRPr lang="en-US" sz="1600" dirty="0"/>
           </a:p>
         </p:txBody>
       </p:sp>
       <p:pic>
         <p:nvPicPr>
-          <p:cNvPr id="13" name="Image 0" descr="C:\Users\Jennyfer\AppData\Local\Temp\claude\C--Users-Jennyfer-Desktop-Proyecto-aplicaciones-web\f2e9f766-196c-42af-8060-d087df4f5bb1\scratchpad\evid\png_nube\P04_reporte.png">    </p:cNvPr>
+          <p:cNvPr id="5" name="Image 0" descr="C:\Users\Jennyfer\AppData\Local\Temp\claude\C--Users-Jennyfer-Desktop-Proyecto-aplicaciones-web\f2e9f766-196c-42af-8060-d087df4f5bb1\scratchpad\evid\png_ui\W02_inicio.png">    </p:cNvPr>
           <p:cNvPicPr>
             <a:picLocks noChangeAspect="1"/>
           </p:cNvPicPr>
@@ -3223,8 +3124,8 @@
         </p:blipFill>
         <p:spPr>
           <a:xfrm>
-            <a:off x="4917643" y="1783080"/>
-            <a:ext cx="5618074" cy="4389120"/>
+            <a:off x="4754880" y="1783080"/>
+            <a:ext cx="6858000" cy="3855742"/>
           </a:xfrm>
           <a:prstGeom prst="rect">
             <a:avLst/>
@@ -3233,7 +3134,7 @@
       </p:pic>
       <p:sp>
         <p:nvSpPr>
-          <p:cNvPr id="14" name="Text 11"/>
+          <p:cNvPr id="6" name="Text 3"/>
           <p:cNvSpPr txBox="1"/>
           <p:nvPr/>
         </p:nvSpPr>
@@ -3272,7 +3173,7 @@
       </p:sp>
       <p:sp>
         <p:nvSpPr>
-          <p:cNvPr id="15" name="Text 12"/>
+          <p:cNvPr id="7" name="Text 4"/>
           <p:cNvSpPr txBox="1"/>
           <p:nvPr/>
         </p:nvSpPr>
@@ -3374,7 +3275,7 @@
                 <a:ea typeface="Arial" pitchFamily="34" charset="-122"/>
                 <a:cs typeface="Arial" pitchFamily="34" charset="-120"/>
               </a:rPr>
-              <a:t>Pruebas de la capa de acceso a datos</a:t>
+              <a:t>Evidencia: colección Postman en la nube</a:t>
             </a:r>
             <a:endParaRPr lang="en-US" sz="3200" dirty="0"/>
           </a:p>
@@ -3413,6 +3314,533 @@
                 <a:ea typeface="Arial" pitchFamily="34" charset="-122"/>
                 <a:cs typeface="Arial" pitchFamily="34" charset="-120"/>
               </a:rPr>
+              <a:t>Ejecutada con Newman contra la URL de Render</a:t>
+            </a:r>
+            <a:endParaRPr lang="en-US" sz="1600" dirty="0"/>
+          </a:p>
+        </p:txBody>
+      </p:sp>
+      <p:sp>
+        <p:nvSpPr>
+          <p:cNvPr id="4" name="Shape 2"/>
+          <p:cNvSpPr/>
+          <p:nvPr/>
+        </p:nvSpPr>
+        <p:spPr>
+          <a:xfrm>
+            <a:off x="548640" y="1783080"/>
+            <a:ext cx="2926080" cy="1280160"/>
+          </a:xfrm>
+          <a:prstGeom prst="roundRect">
+            <a:avLst>
+              <a:gd name="adj" fmla="val 8571"/>
+            </a:avLst>
+          </a:prstGeom>
+          <a:solidFill>
+            <a:srgbClr val="F2F4F7"/>
+          </a:solidFill>
+          <a:ln w="12700">
+            <a:solidFill>
+              <a:srgbClr val="F2F4F7"/>
+            </a:solidFill>
+            <a:prstDash val="solid"/>
+          </a:ln>
+        </p:spPr>
+      </p:sp>
+      <p:sp>
+        <p:nvSpPr>
+          <p:cNvPr id="5" name="Text 3"/>
+          <p:cNvSpPr txBox="1"/>
+          <p:nvPr/>
+        </p:nvSpPr>
+        <p:spPr>
+          <a:xfrm>
+            <a:off x="731520" y="1874520"/>
+            <a:ext cx="2560320" cy="777240"/>
+          </a:xfrm>
+          <a:prstGeom prst="rect">
+            <a:avLst/>
+          </a:prstGeom>
+          <a:noFill/>
+          <a:ln/>
+        </p:spPr>
+        <p:txBody>
+          <a:bodyPr wrap="square" lIns="0" tIns="0" rIns="0" bIns="0" rtlCol="0" anchor="ctr"/>
+          <a:lstStyle/>
+          <a:p>
+            <a:pPr indent="0" marL="0">
+              <a:buNone/>
+            </a:pPr>
+            <a:r>
+              <a:rPr lang="en-US" sz="4400" b="1" dirty="0">
+                <a:solidFill>
+                  <a:srgbClr val="0B3D91"/>
+                </a:solidFill>
+                <a:latin typeface="Arial" pitchFamily="34" charset="0"/>
+                <a:ea typeface="Arial" pitchFamily="34" charset="-122"/>
+                <a:cs typeface="Arial" pitchFamily="34" charset="-120"/>
+              </a:rPr>
+              <a:t>35</a:t>
+            </a:r>
+            <a:endParaRPr lang="en-US" sz="4400" dirty="0"/>
+          </a:p>
+        </p:txBody>
+      </p:sp>
+      <p:sp>
+        <p:nvSpPr>
+          <p:cNvPr id="6" name="Text 4"/>
+          <p:cNvSpPr txBox="1"/>
+          <p:nvPr/>
+        </p:nvSpPr>
+        <p:spPr>
+          <a:xfrm>
+            <a:off x="731520" y="2606040"/>
+            <a:ext cx="2560320" cy="365760"/>
+          </a:xfrm>
+          <a:prstGeom prst="rect">
+            <a:avLst/>
+          </a:prstGeom>
+          <a:noFill/>
+          <a:ln/>
+        </p:spPr>
+        <p:txBody>
+          <a:bodyPr wrap="square" lIns="0" tIns="0" rIns="0" bIns="0" rtlCol="0" anchor="ctr"/>
+          <a:lstStyle/>
+          <a:p>
+            <a:pPr indent="0" marL="0">
+              <a:buNone/>
+            </a:pPr>
+            <a:r>
+              <a:rPr lang="en-US" sz="1500" dirty="0">
+                <a:solidFill>
+                  <a:srgbClr val="5D6D7E"/>
+                </a:solidFill>
+                <a:latin typeface="Arial" pitchFamily="34" charset="0"/>
+                <a:ea typeface="Arial" pitchFamily="34" charset="-122"/>
+                <a:cs typeface="Arial" pitchFamily="34" charset="-120"/>
+              </a:rPr>
+              <a:t>solicitudes</a:t>
+            </a:r>
+            <a:endParaRPr lang="en-US" sz="1500" dirty="0"/>
+          </a:p>
+        </p:txBody>
+      </p:sp>
+      <p:sp>
+        <p:nvSpPr>
+          <p:cNvPr id="7" name="Shape 5"/>
+          <p:cNvSpPr/>
+          <p:nvPr/>
+        </p:nvSpPr>
+        <p:spPr>
+          <a:xfrm>
+            <a:off x="548640" y="3246120"/>
+            <a:ext cx="2926080" cy="1280160"/>
+          </a:xfrm>
+          <a:prstGeom prst="roundRect">
+            <a:avLst>
+              <a:gd name="adj" fmla="val 8571"/>
+            </a:avLst>
+          </a:prstGeom>
+          <a:solidFill>
+            <a:srgbClr val="F2F4F7"/>
+          </a:solidFill>
+          <a:ln w="12700">
+            <a:solidFill>
+              <a:srgbClr val="F2F4F7"/>
+            </a:solidFill>
+            <a:prstDash val="solid"/>
+          </a:ln>
+        </p:spPr>
+      </p:sp>
+      <p:sp>
+        <p:nvSpPr>
+          <p:cNvPr id="8" name="Text 6"/>
+          <p:cNvSpPr txBox="1"/>
+          <p:nvPr/>
+        </p:nvSpPr>
+        <p:spPr>
+          <a:xfrm>
+            <a:off x="731520" y="3337560"/>
+            <a:ext cx="2560320" cy="777240"/>
+          </a:xfrm>
+          <a:prstGeom prst="rect">
+            <a:avLst/>
+          </a:prstGeom>
+          <a:noFill/>
+          <a:ln/>
+        </p:spPr>
+        <p:txBody>
+          <a:bodyPr wrap="square" lIns="0" tIns="0" rIns="0" bIns="0" rtlCol="0" anchor="ctr"/>
+          <a:lstStyle/>
+          <a:p>
+            <a:pPr indent="0" marL="0">
+              <a:buNone/>
+            </a:pPr>
+            <a:r>
+              <a:rPr lang="en-US" sz="4400" b="1" dirty="0">
+                <a:solidFill>
+                  <a:srgbClr val="0B3D91"/>
+                </a:solidFill>
+                <a:latin typeface="Arial" pitchFamily="34" charset="0"/>
+                <a:ea typeface="Arial" pitchFamily="34" charset="-122"/>
+                <a:cs typeface="Arial" pitchFamily="34" charset="-120"/>
+              </a:rPr>
+              <a:t>39</a:t>
+            </a:r>
+            <a:endParaRPr lang="en-US" sz="4400" dirty="0"/>
+          </a:p>
+        </p:txBody>
+      </p:sp>
+      <p:sp>
+        <p:nvSpPr>
+          <p:cNvPr id="9" name="Text 7"/>
+          <p:cNvSpPr txBox="1"/>
+          <p:nvPr/>
+        </p:nvSpPr>
+        <p:spPr>
+          <a:xfrm>
+            <a:off x="731520" y="4069080"/>
+            <a:ext cx="2560320" cy="365760"/>
+          </a:xfrm>
+          <a:prstGeom prst="rect">
+            <a:avLst/>
+          </a:prstGeom>
+          <a:noFill/>
+          <a:ln/>
+        </p:spPr>
+        <p:txBody>
+          <a:bodyPr wrap="square" lIns="0" tIns="0" rIns="0" bIns="0" rtlCol="0" anchor="ctr"/>
+          <a:lstStyle/>
+          <a:p>
+            <a:pPr indent="0" marL="0">
+              <a:buNone/>
+            </a:pPr>
+            <a:r>
+              <a:rPr lang="en-US" sz="1500" dirty="0">
+                <a:solidFill>
+                  <a:srgbClr val="5D6D7E"/>
+                </a:solidFill>
+                <a:latin typeface="Arial" pitchFamily="34" charset="0"/>
+                <a:ea typeface="Arial" pitchFamily="34" charset="-122"/>
+                <a:cs typeface="Arial" pitchFamily="34" charset="-120"/>
+              </a:rPr>
+              <a:t>validaciones</a:t>
+            </a:r>
+            <a:endParaRPr lang="en-US" sz="1500" dirty="0"/>
+          </a:p>
+        </p:txBody>
+      </p:sp>
+      <p:sp>
+        <p:nvSpPr>
+          <p:cNvPr id="10" name="Shape 8"/>
+          <p:cNvSpPr/>
+          <p:nvPr/>
+        </p:nvSpPr>
+        <p:spPr>
+          <a:xfrm>
+            <a:off x="548640" y="4709160"/>
+            <a:ext cx="2926080" cy="1280160"/>
+          </a:xfrm>
+          <a:prstGeom prst="roundRect">
+            <a:avLst>
+              <a:gd name="adj" fmla="val 8571"/>
+            </a:avLst>
+          </a:prstGeom>
+          <a:solidFill>
+            <a:srgbClr val="E3F4EA"/>
+          </a:solidFill>
+          <a:ln w="12700">
+            <a:solidFill>
+              <a:srgbClr val="E3F4EA"/>
+            </a:solidFill>
+            <a:prstDash val="solid"/>
+          </a:ln>
+        </p:spPr>
+      </p:sp>
+      <p:sp>
+        <p:nvSpPr>
+          <p:cNvPr id="11" name="Text 9"/>
+          <p:cNvSpPr txBox="1"/>
+          <p:nvPr/>
+        </p:nvSpPr>
+        <p:spPr>
+          <a:xfrm>
+            <a:off x="731520" y="4800600"/>
+            <a:ext cx="2560320" cy="777240"/>
+          </a:xfrm>
+          <a:prstGeom prst="rect">
+            <a:avLst/>
+          </a:prstGeom>
+          <a:noFill/>
+          <a:ln/>
+        </p:spPr>
+        <p:txBody>
+          <a:bodyPr wrap="square" lIns="0" tIns="0" rIns="0" bIns="0" rtlCol="0" anchor="ctr"/>
+          <a:lstStyle/>
+          <a:p>
+            <a:pPr indent="0" marL="0">
+              <a:buNone/>
+            </a:pPr>
+            <a:r>
+              <a:rPr lang="en-US" sz="4400" b="1" dirty="0">
+                <a:solidFill>
+                  <a:srgbClr val="11763A"/>
+                </a:solidFill>
+                <a:latin typeface="Arial" pitchFamily="34" charset="0"/>
+                <a:ea typeface="Arial" pitchFamily="34" charset="-122"/>
+                <a:cs typeface="Arial" pitchFamily="34" charset="-120"/>
+              </a:rPr>
+              <a:t>0</a:t>
+            </a:r>
+            <a:endParaRPr lang="en-US" sz="4400" dirty="0"/>
+          </a:p>
+        </p:txBody>
+      </p:sp>
+      <p:sp>
+        <p:nvSpPr>
+          <p:cNvPr id="12" name="Text 10"/>
+          <p:cNvSpPr txBox="1"/>
+          <p:nvPr/>
+        </p:nvSpPr>
+        <p:spPr>
+          <a:xfrm>
+            <a:off x="731520" y="5532120"/>
+            <a:ext cx="2560320" cy="365760"/>
+          </a:xfrm>
+          <a:prstGeom prst="rect">
+            <a:avLst/>
+          </a:prstGeom>
+          <a:noFill/>
+          <a:ln/>
+        </p:spPr>
+        <p:txBody>
+          <a:bodyPr wrap="square" lIns="0" tIns="0" rIns="0" bIns="0" rtlCol="0" anchor="ctr"/>
+          <a:lstStyle/>
+          <a:p>
+            <a:pPr indent="0" marL="0">
+              <a:buNone/>
+            </a:pPr>
+            <a:r>
+              <a:rPr lang="en-US" sz="1500" dirty="0">
+                <a:solidFill>
+                  <a:srgbClr val="5D6D7E"/>
+                </a:solidFill>
+                <a:latin typeface="Arial" pitchFamily="34" charset="0"/>
+                <a:ea typeface="Arial" pitchFamily="34" charset="-122"/>
+                <a:cs typeface="Arial" pitchFamily="34" charset="-120"/>
+              </a:rPr>
+              <a:t>fallas</a:t>
+            </a:r>
+            <a:endParaRPr lang="en-US" sz="1500" dirty="0"/>
+          </a:p>
+        </p:txBody>
+      </p:sp>
+      <p:pic>
+        <p:nvPicPr>
+          <p:cNvPr id="13" name="Image 0" descr="C:\Users\Jennyfer\AppData\Local\Temp\claude\C--Users-Jennyfer-Desktop-Proyecto-aplicaciones-web\f2e9f766-196c-42af-8060-d087df4f5bb1\scratchpad\evid\png_nube\P04_reporte.png">    </p:cNvPr>
+          <p:cNvPicPr>
+            <a:picLocks noChangeAspect="1"/>
+          </p:cNvPicPr>
+          <p:nvPr/>
+        </p:nvPicPr>
+        <p:blipFill>
+          <a:blip r:embed="rId1"/>
+          <a:stretch>
+            <a:fillRect/>
+          </a:stretch>
+        </p:blipFill>
+        <p:spPr>
+          <a:xfrm>
+            <a:off x="4917643" y="1783080"/>
+            <a:ext cx="5618074" cy="4389120"/>
+          </a:xfrm>
+          <a:prstGeom prst="rect">
+            <a:avLst/>
+          </a:prstGeom>
+        </p:spPr>
+      </p:pic>
+      <p:sp>
+        <p:nvSpPr>
+          <p:cNvPr id="14" name="Text 11"/>
+          <p:cNvSpPr txBox="1"/>
+          <p:nvPr/>
+        </p:nvSpPr>
+        <p:spPr>
+          <a:xfrm>
+            <a:off x="548640" y="6400800"/>
+            <a:ext cx="5486400" cy="274320"/>
+          </a:xfrm>
+          <a:prstGeom prst="rect">
+            <a:avLst/>
+          </a:prstGeom>
+          <a:noFill/>
+          <a:ln/>
+        </p:spPr>
+        <p:txBody>
+          <a:bodyPr wrap="square" lIns="0" tIns="0" rIns="0" bIns="0" rtlCol="0" anchor="ctr"/>
+          <a:lstStyle/>
+          <a:p>
+            <a:pPr indent="0" marL="0">
+              <a:buNone/>
+            </a:pPr>
+            <a:r>
+              <a:rPr lang="en-US" sz="1000" dirty="0">
+                <a:solidFill>
+                  <a:srgbClr val="5D6D7E"/>
+                </a:solidFill>
+                <a:latin typeface="Arial" pitchFamily="34" charset="0"/>
+                <a:ea typeface="Arial" pitchFamily="34" charset="-122"/>
+                <a:cs typeface="Arial" pitchFamily="34" charset="-120"/>
+              </a:rPr>
+              <a:t>CH&amp;D Rental Pro · DSWII · Grupo 10</a:t>
+            </a:r>
+            <a:endParaRPr lang="en-US" sz="1000" dirty="0"/>
+          </a:p>
+        </p:txBody>
+      </p:sp>
+      <p:sp>
+        <p:nvSpPr>
+          <p:cNvPr id="15" name="Text 12"/>
+          <p:cNvSpPr txBox="1"/>
+          <p:nvPr/>
+        </p:nvSpPr>
+        <p:spPr>
+          <a:xfrm>
+            <a:off x="11155680" y="6400800"/>
+            <a:ext cx="457200" cy="274320"/>
+          </a:xfrm>
+          <a:prstGeom prst="rect">
+            <a:avLst/>
+          </a:prstGeom>
+          <a:noFill/>
+          <a:ln/>
+        </p:spPr>
+        <p:txBody>
+          <a:bodyPr wrap="square" lIns="0" tIns="0" rIns="0" bIns="0" rtlCol="0" anchor="ctr"/>
+          <a:lstStyle/>
+          <a:p>
+            <a:pPr algn="r" indent="0" marL="0">
+              <a:buNone/>
+            </a:pPr>
+            <a:r>
+              <a:rPr lang="en-US" sz="1000" dirty="0">
+                <a:solidFill>
+                  <a:srgbClr val="5D6D7E"/>
+                </a:solidFill>
+                <a:latin typeface="Arial" pitchFamily="34" charset="0"/>
+                <a:ea typeface="Arial" pitchFamily="34" charset="-122"/>
+                <a:cs typeface="Arial" pitchFamily="34" charset="-120"/>
+              </a:rPr>
+              <a:t>12</a:t>
+            </a:r>
+            <a:endParaRPr lang="en-US" sz="1000" dirty="0"/>
+          </a:p>
+        </p:txBody>
+      </p:sp>
+    </p:spTree>
+  </p:cSld>
+  <p:clrMapOvr>
+    <a:masterClrMapping/>
+  </p:clrMapOvr>
+</p:sld>
+</file>
+
+<file path=ppt/slides/slide13.xml><?xml version="1.0" encoding="utf-8"?>
+<p:sld xmlns:a="http://schemas.openxmlformats.org/drawingml/2006/main" xmlns:r="http://schemas.openxmlformats.org/officeDocument/2006/relationships" xmlns:p="http://schemas.openxmlformats.org/presentationml/2006/main">
+  <p:cSld name="Slide 13">
+    <p:bg>
+      <p:bgPr>
+        <a:solidFill>
+          <a:srgbClr val="FFFFFF"/>
+        </a:solidFill>
+      </p:bgPr>
+    </p:bg>
+    <p:spTree>
+      <p:nvGrpSpPr>
+        <p:cNvPr id="1" name=""/>
+        <p:cNvGrpSpPr/>
+        <p:nvPr/>
+      </p:nvGrpSpPr>
+      <p:grpSpPr>
+        <a:xfrm>
+          <a:off x="0" y="0"/>
+          <a:ext cx="0" cy="0"/>
+          <a:chOff x="0" y="0"/>
+          <a:chExt cx="0" cy="0"/>
+        </a:xfrm>
+      </p:grpSpPr>
+      <p:sp>
+        <p:nvSpPr>
+          <p:cNvPr id="2" name="Text 0"/>
+          <p:cNvSpPr txBox="1"/>
+          <p:nvPr/>
+        </p:nvSpPr>
+        <p:spPr>
+          <a:xfrm>
+            <a:off x="548640" y="365760"/>
+            <a:ext cx="11064240" cy="731520"/>
+          </a:xfrm>
+          <a:prstGeom prst="rect">
+            <a:avLst/>
+          </a:prstGeom>
+          <a:noFill/>
+          <a:ln/>
+        </p:spPr>
+        <p:txBody>
+          <a:bodyPr wrap="square" lIns="0" tIns="0" rIns="0" bIns="0" rtlCol="0" anchor="ctr"/>
+          <a:lstStyle/>
+          <a:p>
+            <a:pPr indent="0" marL="0">
+              <a:buNone/>
+            </a:pPr>
+            <a:r>
+              <a:rPr lang="en-US" sz="3200" b="1" dirty="0">
+                <a:solidFill>
+                  <a:srgbClr val="1B2631"/>
+                </a:solidFill>
+                <a:latin typeface="Arial" pitchFamily="34" charset="0"/>
+                <a:ea typeface="Arial" pitchFamily="34" charset="-122"/>
+                <a:cs typeface="Arial" pitchFamily="34" charset="-120"/>
+              </a:rPr>
+              <a:t>Pruebas de la capa de acceso a datos</a:t>
+            </a:r>
+            <a:endParaRPr lang="en-US" sz="3200" dirty="0"/>
+          </a:p>
+        </p:txBody>
+      </p:sp>
+      <p:sp>
+        <p:nvSpPr>
+          <p:cNvPr id="3" name="Text 1"/>
+          <p:cNvSpPr txBox="1"/>
+          <p:nvPr/>
+        </p:nvSpPr>
+        <p:spPr>
+          <a:xfrm>
+            <a:off x="548640" y="1051560"/>
+            <a:ext cx="11064240" cy="411480"/>
+          </a:xfrm>
+          <a:prstGeom prst="rect">
+            <a:avLst/>
+          </a:prstGeom>
+          <a:noFill/>
+          <a:ln/>
+        </p:spPr>
+        <p:txBody>
+          <a:bodyPr wrap="square" lIns="0" tIns="0" rIns="0" bIns="0" rtlCol="0" anchor="ctr"/>
+          <a:lstStyle/>
+          <a:p>
+            <a:pPr indent="0" marL="0">
+              <a:buNone/>
+            </a:pPr>
+            <a:r>
+              <a:rPr lang="en-US" sz="1600" dirty="0">
+                <a:solidFill>
+                  <a:srgbClr val="5D6D7E"/>
+                </a:solidFill>
+                <a:latin typeface="Arial" pitchFamily="34" charset="0"/>
+                <a:ea typeface="Arial" pitchFamily="34" charset="-122"/>
+                <a:cs typeface="Arial" pitchFamily="34" charset="-120"/>
+              </a:rPr>
               <a:t>@DataJpaTest sobre H2 en modo PostgreSQL · se ejecutan con mvn test</a:t>
             </a:r>
             <a:endParaRPr lang="en-US" sz="1600" dirty="0"/>
@@ -3421,7 +3849,7 @@
       </p:sp>
       <p:graphicFrame>
         <p:nvGraphicFramePr>
-          <p:cNvPr id="13" name="Table 0"/>
+          <p:cNvPr id="14" name="Table 0"/>
           <p:cNvGraphicFramePr>
             <a:graphicFrameLocks noGrp="1"/>
           </p:cNvGraphicFramePr>
@@ -6062,812 +6490,6 @@
                 <a:ea typeface="Arial" pitchFamily="34" charset="-122"/>
                 <a:cs typeface="Arial" pitchFamily="34" charset="-120"/>
               </a:rPr>
-              <a:t>12</a:t>
-            </a:r>
-            <a:endParaRPr lang="en-US" sz="1000" dirty="0"/>
-          </a:p>
-        </p:txBody>
-      </p:sp>
-    </p:spTree>
-  </p:cSld>
-  <p:clrMapOvr>
-    <a:masterClrMapping/>
-  </p:clrMapOvr>
-</p:sld>
-</file>
-
-<file path=ppt/slides/slide13.xml><?xml version="1.0" encoding="utf-8"?>
-<p:sld xmlns:a="http://schemas.openxmlformats.org/drawingml/2006/main" xmlns:r="http://schemas.openxmlformats.org/officeDocument/2006/relationships" xmlns:p="http://schemas.openxmlformats.org/presentationml/2006/main">
-  <p:cSld name="Slide 13">
-    <p:bg>
-      <p:bgPr>
-        <a:solidFill>
-          <a:srgbClr val="FFFFFF"/>
-        </a:solidFill>
-      </p:bgPr>
-    </p:bg>
-    <p:spTree>
-      <p:nvGrpSpPr>
-        <p:cNvPr id="1" name=""/>
-        <p:cNvGrpSpPr/>
-        <p:nvPr/>
-      </p:nvGrpSpPr>
-      <p:grpSpPr>
-        <a:xfrm>
-          <a:off x="0" y="0"/>
-          <a:ext cx="0" cy="0"/>
-          <a:chOff x="0" y="0"/>
-          <a:chExt cx="0" cy="0"/>
-        </a:xfrm>
-      </p:grpSpPr>
-      <p:sp>
-        <p:nvSpPr>
-          <p:cNvPr id="2" name="Text 0"/>
-          <p:cNvSpPr txBox="1"/>
-          <p:nvPr/>
-        </p:nvSpPr>
-        <p:spPr>
-          <a:xfrm>
-            <a:off x="548640" y="365760"/>
-            <a:ext cx="11064240" cy="731520"/>
-          </a:xfrm>
-          <a:prstGeom prst="rect">
-            <a:avLst/>
-          </a:prstGeom>
-          <a:noFill/>
-          <a:ln/>
-        </p:spPr>
-        <p:txBody>
-          <a:bodyPr wrap="square" lIns="0" tIns="0" rIns="0" bIns="0" rtlCol="0" anchor="ctr"/>
-          <a:lstStyle/>
-          <a:p>
-            <a:pPr indent="0" marL="0">
-              <a:buNone/>
-            </a:pPr>
-            <a:r>
-              <a:rPr lang="en-US" sz="3200" b="1" dirty="0">
-                <a:solidFill>
-                  <a:srgbClr val="1B2631"/>
-                </a:solidFill>
-                <a:latin typeface="Arial" pitchFamily="34" charset="0"/>
-                <a:ea typeface="Arial" pitchFamily="34" charset="-122"/>
-                <a:cs typeface="Arial" pitchFamily="34" charset="-120"/>
-              </a:rPr>
-              <a:t>Demostración en vivo</a:t>
-            </a:r>
-            <a:endParaRPr lang="en-US" sz="3200" dirty="0"/>
-          </a:p>
-        </p:txBody>
-      </p:sp>
-      <p:sp>
-        <p:nvSpPr>
-          <p:cNvPr id="3" name="Text 1"/>
-          <p:cNvSpPr txBox="1"/>
-          <p:nvPr/>
-        </p:nvSpPr>
-        <p:spPr>
-          <a:xfrm>
-            <a:off x="548640" y="1051560"/>
-            <a:ext cx="11064240" cy="411480"/>
-          </a:xfrm>
-          <a:prstGeom prst="rect">
-            <a:avLst/>
-          </a:prstGeom>
-          <a:noFill/>
-          <a:ln/>
-        </p:spPr>
-        <p:txBody>
-          <a:bodyPr wrap="square" lIns="0" tIns="0" rIns="0" bIns="0" rtlCol="0" anchor="ctr"/>
-          <a:lstStyle/>
-          <a:p>
-            <a:pPr indent="0" marL="0">
-              <a:buNone/>
-            </a:pPr>
-            <a:r>
-              <a:rPr lang="en-US" sz="1600" dirty="0">
-                <a:solidFill>
-                  <a:srgbClr val="5D6D7E"/>
-                </a:solidFill>
-                <a:latin typeface="Arial" pitchFamily="34" charset="0"/>
-                <a:ea typeface="Arial" pitchFamily="34" charset="-122"/>
-                <a:cs typeface="Arial" pitchFamily="34" charset="-120"/>
-              </a:rPr>
-              <a:t>Sobre la URL de Render, con Postman o Swagger</a:t>
-            </a:r>
-            <a:endParaRPr lang="en-US" sz="1600" dirty="0"/>
-          </a:p>
-        </p:txBody>
-      </p:sp>
-      <p:sp>
-        <p:nvSpPr>
-          <p:cNvPr id="4" name="Shape 2"/>
-          <p:cNvSpPr/>
-          <p:nvPr/>
-        </p:nvSpPr>
-        <p:spPr>
-          <a:xfrm>
-            <a:off x="548640" y="1783080"/>
-            <a:ext cx="502920" cy="502920"/>
-          </a:xfrm>
-          <a:prstGeom prst="ellipse">
-            <a:avLst/>
-          </a:prstGeom>
-          <a:solidFill>
-            <a:srgbClr val="0B3D91"/>
-          </a:solidFill>
-          <a:ln w="12700">
-            <a:solidFill>
-              <a:srgbClr val="0B3D91"/>
-            </a:solidFill>
-            <a:prstDash val="solid"/>
-          </a:ln>
-        </p:spPr>
-      </p:sp>
-      <p:sp>
-        <p:nvSpPr>
-          <p:cNvPr id="5" name="Text 3"/>
-          <p:cNvSpPr txBox="1"/>
-          <p:nvPr/>
-        </p:nvSpPr>
-        <p:spPr>
-          <a:xfrm>
-            <a:off x="548640" y="1783080"/>
-            <a:ext cx="502920" cy="502920"/>
-          </a:xfrm>
-          <a:prstGeom prst="rect">
-            <a:avLst/>
-          </a:prstGeom>
-          <a:noFill/>
-          <a:ln/>
-        </p:spPr>
-        <p:txBody>
-          <a:bodyPr wrap="square" lIns="0" tIns="0" rIns="0" bIns="0" rtlCol="0" anchor="ctr"/>
-          <a:lstStyle/>
-          <a:p>
-            <a:pPr algn="ctr" indent="0" marL="0">
-              <a:buNone/>
-            </a:pPr>
-            <a:r>
-              <a:rPr lang="en-US" sz="1500" b="1" dirty="0">
-                <a:solidFill>
-                  <a:srgbClr val="FFFFFF"/>
-                </a:solidFill>
-                <a:latin typeface="Arial" pitchFamily="34" charset="0"/>
-                <a:ea typeface="Arial" pitchFamily="34" charset="-122"/>
-                <a:cs typeface="Arial" pitchFamily="34" charset="-120"/>
-              </a:rPr>
-              <a:t>1</a:t>
-            </a:r>
-            <a:endParaRPr lang="en-US" sz="1500" dirty="0"/>
-          </a:p>
-        </p:txBody>
-      </p:sp>
-      <p:sp>
-        <p:nvSpPr>
-          <p:cNvPr id="6" name="Text 4"/>
-          <p:cNvSpPr txBox="1"/>
-          <p:nvPr/>
-        </p:nvSpPr>
-        <p:spPr>
-          <a:xfrm>
-            <a:off x="1280160" y="1783080"/>
-            <a:ext cx="10241280" cy="502920"/>
-          </a:xfrm>
-          <a:prstGeom prst="rect">
-            <a:avLst/>
-          </a:prstGeom>
-          <a:noFill/>
-          <a:ln/>
-        </p:spPr>
-        <p:txBody>
-          <a:bodyPr wrap="square" lIns="0" tIns="0" rIns="0" bIns="0" rtlCol="0" anchor="ctr"/>
-          <a:lstStyle/>
-          <a:p>
-            <a:pPr indent="0" marL="0">
-              <a:buNone/>
-            </a:pPr>
-            <a:r>
-              <a:rPr lang="en-US" sz="1700" dirty="0">
-                <a:solidFill>
-                  <a:srgbClr val="1B2631"/>
-                </a:solidFill>
-                <a:latin typeface="Arial" pitchFamily="34" charset="0"/>
-                <a:ea typeface="Arial" pitchFamily="34" charset="-122"/>
-                <a:cs typeface="Arial" pitchFamily="34" charset="-120"/>
-              </a:rPr>
-              <a:t>Login con admin → token JWT; login con clave errónea → 401</a:t>
-            </a:r>
-            <a:endParaRPr lang="en-US" sz="1700" dirty="0"/>
-          </a:p>
-        </p:txBody>
-      </p:sp>
-      <p:sp>
-        <p:nvSpPr>
-          <p:cNvPr id="7" name="Shape 5"/>
-          <p:cNvSpPr/>
-          <p:nvPr/>
-        </p:nvSpPr>
-        <p:spPr>
-          <a:xfrm>
-            <a:off x="548640" y="2496312"/>
-            <a:ext cx="502920" cy="502920"/>
-          </a:xfrm>
-          <a:prstGeom prst="ellipse">
-            <a:avLst/>
-          </a:prstGeom>
-          <a:solidFill>
-            <a:srgbClr val="0B3D91"/>
-          </a:solidFill>
-          <a:ln w="12700">
-            <a:solidFill>
-              <a:srgbClr val="0B3D91"/>
-            </a:solidFill>
-            <a:prstDash val="solid"/>
-          </a:ln>
-        </p:spPr>
-      </p:sp>
-      <p:sp>
-        <p:nvSpPr>
-          <p:cNvPr id="8" name="Text 6"/>
-          <p:cNvSpPr txBox="1"/>
-          <p:nvPr/>
-        </p:nvSpPr>
-        <p:spPr>
-          <a:xfrm>
-            <a:off x="548640" y="2496312"/>
-            <a:ext cx="502920" cy="502920"/>
-          </a:xfrm>
-          <a:prstGeom prst="rect">
-            <a:avLst/>
-          </a:prstGeom>
-          <a:noFill/>
-          <a:ln/>
-        </p:spPr>
-        <p:txBody>
-          <a:bodyPr wrap="square" lIns="0" tIns="0" rIns="0" bIns="0" rtlCol="0" anchor="ctr"/>
-          <a:lstStyle/>
-          <a:p>
-            <a:pPr algn="ctr" indent="0" marL="0">
-              <a:buNone/>
-            </a:pPr>
-            <a:r>
-              <a:rPr lang="en-US" sz="1500" b="1" dirty="0">
-                <a:solidFill>
-                  <a:srgbClr val="FFFFFF"/>
-                </a:solidFill>
-                <a:latin typeface="Arial" pitchFamily="34" charset="0"/>
-                <a:ea typeface="Arial" pitchFamily="34" charset="-122"/>
-                <a:cs typeface="Arial" pitchFamily="34" charset="-120"/>
-              </a:rPr>
-              <a:t>2</a:t>
-            </a:r>
-            <a:endParaRPr lang="en-US" sz="1500" dirty="0"/>
-          </a:p>
-        </p:txBody>
-      </p:sp>
-      <p:sp>
-        <p:nvSpPr>
-          <p:cNvPr id="9" name="Text 7"/>
-          <p:cNvSpPr txBox="1"/>
-          <p:nvPr/>
-        </p:nvSpPr>
-        <p:spPr>
-          <a:xfrm>
-            <a:off x="1280160" y="2496312"/>
-            <a:ext cx="10241280" cy="502920"/>
-          </a:xfrm>
-          <a:prstGeom prst="rect">
-            <a:avLst/>
-          </a:prstGeom>
-          <a:noFill/>
-          <a:ln/>
-        </p:spPr>
-        <p:txBody>
-          <a:bodyPr wrap="square" lIns="0" tIns="0" rIns="0" bIns="0" rtlCol="0" anchor="ctr"/>
-          <a:lstStyle/>
-          <a:p>
-            <a:pPr indent="0" marL="0">
-              <a:buNone/>
-            </a:pPr>
-            <a:r>
-              <a:rPr lang="en-US" sz="1700" dirty="0">
-                <a:solidFill>
-                  <a:srgbClr val="1B2631"/>
-                </a:solidFill>
-                <a:latin typeface="Arial" pitchFamily="34" charset="0"/>
-                <a:ea typeface="Arial" pitchFamily="34" charset="-122"/>
-                <a:cs typeface="Arial" pitchFamily="34" charset="-120"/>
-              </a:rPr>
-              <a:t>GET de vehículos y POST de un cliente nuevo (201)</a:t>
-            </a:r>
-            <a:endParaRPr lang="en-US" sz="1700" dirty="0"/>
-          </a:p>
-        </p:txBody>
-      </p:sp>
-      <p:sp>
-        <p:nvSpPr>
-          <p:cNvPr id="10" name="Shape 8"/>
-          <p:cNvSpPr/>
-          <p:nvPr/>
-        </p:nvSpPr>
-        <p:spPr>
-          <a:xfrm>
-            <a:off x="548640" y="3209544"/>
-            <a:ext cx="502920" cy="502920"/>
-          </a:xfrm>
-          <a:prstGeom prst="ellipse">
-            <a:avLst/>
-          </a:prstGeom>
-          <a:solidFill>
-            <a:srgbClr val="0B3D91"/>
-          </a:solidFill>
-          <a:ln w="12700">
-            <a:solidFill>
-              <a:srgbClr val="0B3D91"/>
-            </a:solidFill>
-            <a:prstDash val="solid"/>
-          </a:ln>
-        </p:spPr>
-      </p:sp>
-      <p:sp>
-        <p:nvSpPr>
-          <p:cNvPr id="11" name="Text 9"/>
-          <p:cNvSpPr txBox="1"/>
-          <p:nvPr/>
-        </p:nvSpPr>
-        <p:spPr>
-          <a:xfrm>
-            <a:off x="548640" y="3209544"/>
-            <a:ext cx="502920" cy="502920"/>
-          </a:xfrm>
-          <a:prstGeom prst="rect">
-            <a:avLst/>
-          </a:prstGeom>
-          <a:noFill/>
-          <a:ln/>
-        </p:spPr>
-        <p:txBody>
-          <a:bodyPr wrap="square" lIns="0" tIns="0" rIns="0" bIns="0" rtlCol="0" anchor="ctr"/>
-          <a:lstStyle/>
-          <a:p>
-            <a:pPr algn="ctr" indent="0" marL="0">
-              <a:buNone/>
-            </a:pPr>
-            <a:r>
-              <a:rPr lang="en-US" sz="1500" b="1" dirty="0">
-                <a:solidFill>
-                  <a:srgbClr val="FFFFFF"/>
-                </a:solidFill>
-                <a:latin typeface="Arial" pitchFamily="34" charset="0"/>
-                <a:ea typeface="Arial" pitchFamily="34" charset="-122"/>
-                <a:cs typeface="Arial" pitchFamily="34" charset="-120"/>
-              </a:rPr>
-              <a:t>3</a:t>
-            </a:r>
-            <a:endParaRPr lang="en-US" sz="1500" dirty="0"/>
-          </a:p>
-        </p:txBody>
-      </p:sp>
-      <p:sp>
-        <p:nvSpPr>
-          <p:cNvPr id="12" name="Text 10"/>
-          <p:cNvSpPr txBox="1"/>
-          <p:nvPr/>
-        </p:nvSpPr>
-        <p:spPr>
-          <a:xfrm>
-            <a:off x="1280160" y="3209544"/>
-            <a:ext cx="10241280" cy="502920"/>
-          </a:xfrm>
-          <a:prstGeom prst="rect">
-            <a:avLst/>
-          </a:prstGeom>
-          <a:noFill/>
-          <a:ln/>
-        </p:spPr>
-        <p:txBody>
-          <a:bodyPr wrap="square" lIns="0" tIns="0" rIns="0" bIns="0" rtlCol="0" anchor="ctr"/>
-          <a:lstStyle/>
-          <a:p>
-            <a:pPr indent="0" marL="0">
-              <a:buNone/>
-            </a:pPr>
-            <a:r>
-              <a:rPr lang="en-US" sz="1700" dirty="0">
-                <a:solidFill>
-                  <a:srgbClr val="1B2631"/>
-                </a:solidFill>
-                <a:latin typeface="Arial" pitchFamily="34" charset="0"/>
-                <a:ea typeface="Arial" pitchFamily="34" charset="-122"/>
-                <a:cs typeface="Arial" pitchFamily="34" charset="-120"/>
-              </a:rPr>
-              <a:t>PUT del cliente (200) y DELETE (204); GET posterior → 404</a:t>
-            </a:r>
-            <a:endParaRPr lang="en-US" sz="1700" dirty="0"/>
-          </a:p>
-        </p:txBody>
-      </p:sp>
-      <p:sp>
-        <p:nvSpPr>
-          <p:cNvPr id="13" name="Shape 11"/>
-          <p:cNvSpPr/>
-          <p:nvPr/>
-        </p:nvSpPr>
-        <p:spPr>
-          <a:xfrm>
-            <a:off x="548640" y="3922776"/>
-            <a:ext cx="502920" cy="502920"/>
-          </a:xfrm>
-          <a:prstGeom prst="ellipse">
-            <a:avLst/>
-          </a:prstGeom>
-          <a:solidFill>
-            <a:srgbClr val="0B3D91"/>
-          </a:solidFill>
-          <a:ln w="12700">
-            <a:solidFill>
-              <a:srgbClr val="0B3D91"/>
-            </a:solidFill>
-            <a:prstDash val="solid"/>
-          </a:ln>
-        </p:spPr>
-      </p:sp>
-      <p:sp>
-        <p:nvSpPr>
-          <p:cNvPr id="14" name="Text 12"/>
-          <p:cNvSpPr txBox="1"/>
-          <p:nvPr/>
-        </p:nvSpPr>
-        <p:spPr>
-          <a:xfrm>
-            <a:off x="548640" y="3922776"/>
-            <a:ext cx="502920" cy="502920"/>
-          </a:xfrm>
-          <a:prstGeom prst="rect">
-            <a:avLst/>
-          </a:prstGeom>
-          <a:noFill/>
-          <a:ln/>
-        </p:spPr>
-        <p:txBody>
-          <a:bodyPr wrap="square" lIns="0" tIns="0" rIns="0" bIns="0" rtlCol="0" anchor="ctr"/>
-          <a:lstStyle/>
-          <a:p>
-            <a:pPr algn="ctr" indent="0" marL="0">
-              <a:buNone/>
-            </a:pPr>
-            <a:r>
-              <a:rPr lang="en-US" sz="1500" b="1" dirty="0">
-                <a:solidFill>
-                  <a:srgbClr val="FFFFFF"/>
-                </a:solidFill>
-                <a:latin typeface="Arial" pitchFamily="34" charset="0"/>
-                <a:ea typeface="Arial" pitchFamily="34" charset="-122"/>
-                <a:cs typeface="Arial" pitchFamily="34" charset="-120"/>
-              </a:rPr>
-              <a:t>4</a:t>
-            </a:r>
-            <a:endParaRPr lang="en-US" sz="1500" dirty="0"/>
-          </a:p>
-        </p:txBody>
-      </p:sp>
-      <p:sp>
-        <p:nvSpPr>
-          <p:cNvPr id="15" name="Text 13"/>
-          <p:cNvSpPr txBox="1"/>
-          <p:nvPr/>
-        </p:nvSpPr>
-        <p:spPr>
-          <a:xfrm>
-            <a:off x="1280160" y="3922776"/>
-            <a:ext cx="10241280" cy="502920"/>
-          </a:xfrm>
-          <a:prstGeom prst="rect">
-            <a:avLst/>
-          </a:prstGeom>
-          <a:noFill/>
-          <a:ln/>
-        </p:spPr>
-        <p:txBody>
-          <a:bodyPr wrap="square" lIns="0" tIns="0" rIns="0" bIns="0" rtlCol="0" anchor="ctr"/>
-          <a:lstStyle/>
-          <a:p>
-            <a:pPr indent="0" marL="0">
-              <a:buNone/>
-            </a:pPr>
-            <a:r>
-              <a:rPr lang="en-US" sz="1700" dirty="0">
-                <a:solidFill>
-                  <a:srgbClr val="1B2631"/>
-                </a:solidFill>
-                <a:latin typeface="Arial" pitchFamily="34" charset="0"/>
-                <a:ea typeface="Arial" pitchFamily="34" charset="-122"/>
-                <a:cs typeface="Arial" pitchFamily="34" charset="-120"/>
-              </a:rPr>
-              <a:t>POST de contrato: IGV y total calculados; mismo vehículo y fechas → 409</a:t>
-            </a:r>
-            <a:endParaRPr lang="en-US" sz="1700" dirty="0"/>
-          </a:p>
-        </p:txBody>
-      </p:sp>
-      <p:sp>
-        <p:nvSpPr>
-          <p:cNvPr id="16" name="Shape 14"/>
-          <p:cNvSpPr/>
-          <p:nvPr/>
-        </p:nvSpPr>
-        <p:spPr>
-          <a:xfrm>
-            <a:off x="548640" y="4636008"/>
-            <a:ext cx="502920" cy="502920"/>
-          </a:xfrm>
-          <a:prstGeom prst="ellipse">
-            <a:avLst/>
-          </a:prstGeom>
-          <a:solidFill>
-            <a:srgbClr val="0B3D91"/>
-          </a:solidFill>
-          <a:ln w="12700">
-            <a:solidFill>
-              <a:srgbClr val="0B3D91"/>
-            </a:solidFill>
-            <a:prstDash val="solid"/>
-          </a:ln>
-        </p:spPr>
-      </p:sp>
-      <p:sp>
-        <p:nvSpPr>
-          <p:cNvPr id="17" name="Text 15"/>
-          <p:cNvSpPr txBox="1"/>
-          <p:nvPr/>
-        </p:nvSpPr>
-        <p:spPr>
-          <a:xfrm>
-            <a:off x="548640" y="4636008"/>
-            <a:ext cx="502920" cy="502920"/>
-          </a:xfrm>
-          <a:prstGeom prst="rect">
-            <a:avLst/>
-          </a:prstGeom>
-          <a:noFill/>
-          <a:ln/>
-        </p:spPr>
-        <p:txBody>
-          <a:bodyPr wrap="square" lIns="0" tIns="0" rIns="0" bIns="0" rtlCol="0" anchor="ctr"/>
-          <a:lstStyle/>
-          <a:p>
-            <a:pPr algn="ctr" indent="0" marL="0">
-              <a:buNone/>
-            </a:pPr>
-            <a:r>
-              <a:rPr lang="en-US" sz="1500" b="1" dirty="0">
-                <a:solidFill>
-                  <a:srgbClr val="FFFFFF"/>
-                </a:solidFill>
-                <a:latin typeface="Arial" pitchFamily="34" charset="0"/>
-                <a:ea typeface="Arial" pitchFamily="34" charset="-122"/>
-                <a:cs typeface="Arial" pitchFamily="34" charset="-120"/>
-              </a:rPr>
-              <a:t>5</a:t>
-            </a:r>
-            <a:endParaRPr lang="en-US" sz="1500" dirty="0"/>
-          </a:p>
-        </p:txBody>
-      </p:sp>
-      <p:sp>
-        <p:nvSpPr>
-          <p:cNvPr id="18" name="Text 16"/>
-          <p:cNvSpPr txBox="1"/>
-          <p:nvPr/>
-        </p:nvSpPr>
-        <p:spPr>
-          <a:xfrm>
-            <a:off x="1280160" y="4636008"/>
-            <a:ext cx="10241280" cy="502920"/>
-          </a:xfrm>
-          <a:prstGeom prst="rect">
-            <a:avLst/>
-          </a:prstGeom>
-          <a:noFill/>
-          <a:ln/>
-        </p:spPr>
-        <p:txBody>
-          <a:bodyPr wrap="square" lIns="0" tIns="0" rIns="0" bIns="0" rtlCol="0" anchor="ctr"/>
-          <a:lstStyle/>
-          <a:p>
-            <a:pPr indent="0" marL="0">
-              <a:buNone/>
-            </a:pPr>
-            <a:r>
-              <a:rPr lang="en-US" sz="1700" dirty="0">
-                <a:solidFill>
-                  <a:srgbClr val="1B2631"/>
-                </a:solidFill>
-                <a:latin typeface="Arial" pitchFamily="34" charset="0"/>
-                <a:ea typeface="Arial" pitchFamily="34" charset="-122"/>
-                <a:cs typeface="Arial" pitchFamily="34" charset="-120"/>
-              </a:rPr>
-              <a:t>DELETE con rol OPERADOR → 403 (solo ADMIN elimina)</a:t>
-            </a:r>
-            <a:endParaRPr lang="en-US" sz="1700" dirty="0"/>
-          </a:p>
-        </p:txBody>
-      </p:sp>
-      <p:sp>
-        <p:nvSpPr>
-          <p:cNvPr id="19" name="Shape 17"/>
-          <p:cNvSpPr/>
-          <p:nvPr/>
-        </p:nvSpPr>
-        <p:spPr>
-          <a:xfrm>
-            <a:off x="548640" y="5349240"/>
-            <a:ext cx="502920" cy="502920"/>
-          </a:xfrm>
-          <a:prstGeom prst="ellipse">
-            <a:avLst/>
-          </a:prstGeom>
-          <a:solidFill>
-            <a:srgbClr val="0B3D91"/>
-          </a:solidFill>
-          <a:ln w="12700">
-            <a:solidFill>
-              <a:srgbClr val="0B3D91"/>
-            </a:solidFill>
-            <a:prstDash val="solid"/>
-          </a:ln>
-        </p:spPr>
-      </p:sp>
-      <p:sp>
-        <p:nvSpPr>
-          <p:cNvPr id="20" name="Text 18"/>
-          <p:cNvSpPr txBox="1"/>
-          <p:nvPr/>
-        </p:nvSpPr>
-        <p:spPr>
-          <a:xfrm>
-            <a:off x="548640" y="5349240"/>
-            <a:ext cx="502920" cy="502920"/>
-          </a:xfrm>
-          <a:prstGeom prst="rect">
-            <a:avLst/>
-          </a:prstGeom>
-          <a:noFill/>
-          <a:ln/>
-        </p:spPr>
-        <p:txBody>
-          <a:bodyPr wrap="square" lIns="0" tIns="0" rIns="0" bIns="0" rtlCol="0" anchor="ctr"/>
-          <a:lstStyle/>
-          <a:p>
-            <a:pPr algn="ctr" indent="0" marL="0">
-              <a:buNone/>
-            </a:pPr>
-            <a:r>
-              <a:rPr lang="en-US" sz="1500" b="1" dirty="0">
-                <a:solidFill>
-                  <a:srgbClr val="FFFFFF"/>
-                </a:solidFill>
-                <a:latin typeface="Arial" pitchFamily="34" charset="0"/>
-                <a:ea typeface="Arial" pitchFamily="34" charset="-122"/>
-                <a:cs typeface="Arial" pitchFamily="34" charset="-120"/>
-              </a:rPr>
-              <a:t>6</a:t>
-            </a:r>
-            <a:endParaRPr lang="en-US" sz="1500" dirty="0"/>
-          </a:p>
-        </p:txBody>
-      </p:sp>
-      <p:sp>
-        <p:nvSpPr>
-          <p:cNvPr id="21" name="Text 19"/>
-          <p:cNvSpPr txBox="1"/>
-          <p:nvPr/>
-        </p:nvSpPr>
-        <p:spPr>
-          <a:xfrm>
-            <a:off x="1280160" y="5349240"/>
-            <a:ext cx="10241280" cy="502920"/>
-          </a:xfrm>
-          <a:prstGeom prst="rect">
-            <a:avLst/>
-          </a:prstGeom>
-          <a:noFill/>
-          <a:ln/>
-        </p:spPr>
-        <p:txBody>
-          <a:bodyPr wrap="square" lIns="0" tIns="0" rIns="0" bIns="0" rtlCol="0" anchor="ctr"/>
-          <a:lstStyle/>
-          <a:p>
-            <a:pPr indent="0" marL="0">
-              <a:buNone/>
-            </a:pPr>
-            <a:r>
-              <a:rPr lang="en-US" sz="1700" dirty="0">
-                <a:solidFill>
-                  <a:srgbClr val="1B2631"/>
-                </a:solidFill>
-                <a:latin typeface="Arial" pitchFamily="34" charset="0"/>
-                <a:ea typeface="Arial" pitchFamily="34" charset="-122"/>
-                <a:cs typeface="Arial" pitchFamily="34" charset="-120"/>
-              </a:rPr>
-              <a:t>mvn test: 42 pruebas en verde</a:t>
-            </a:r>
-            <a:endParaRPr lang="en-US" sz="1700" dirty="0"/>
-          </a:p>
-        </p:txBody>
-      </p:sp>
-      <p:sp>
-        <p:nvSpPr>
-          <p:cNvPr id="22" name="Text 20"/>
-          <p:cNvSpPr txBox="1"/>
-          <p:nvPr/>
-        </p:nvSpPr>
-        <p:spPr>
-          <a:xfrm>
-            <a:off x="548640" y="6400800"/>
-            <a:ext cx="5486400" cy="274320"/>
-          </a:xfrm>
-          <a:prstGeom prst="rect">
-            <a:avLst/>
-          </a:prstGeom>
-          <a:noFill/>
-          <a:ln/>
-        </p:spPr>
-        <p:txBody>
-          <a:bodyPr wrap="square" lIns="0" tIns="0" rIns="0" bIns="0" rtlCol="0" anchor="ctr"/>
-          <a:lstStyle/>
-          <a:p>
-            <a:pPr indent="0" marL="0">
-              <a:buNone/>
-            </a:pPr>
-            <a:r>
-              <a:rPr lang="en-US" sz="1000" dirty="0">
-                <a:solidFill>
-                  <a:srgbClr val="5D6D7E"/>
-                </a:solidFill>
-                <a:latin typeface="Arial" pitchFamily="34" charset="0"/>
-                <a:ea typeface="Arial" pitchFamily="34" charset="-122"/>
-                <a:cs typeface="Arial" pitchFamily="34" charset="-120"/>
-              </a:rPr>
-              <a:t>CH&amp;D Rental Pro · DSWII · Grupo 10</a:t>
-            </a:r>
-            <a:endParaRPr lang="en-US" sz="1000" dirty="0"/>
-          </a:p>
-        </p:txBody>
-      </p:sp>
-      <p:sp>
-        <p:nvSpPr>
-          <p:cNvPr id="23" name="Text 21"/>
-          <p:cNvSpPr txBox="1"/>
-          <p:nvPr/>
-        </p:nvSpPr>
-        <p:spPr>
-          <a:xfrm>
-            <a:off x="11155680" y="6400800"/>
-            <a:ext cx="457200" cy="274320"/>
-          </a:xfrm>
-          <a:prstGeom prst="rect">
-            <a:avLst/>
-          </a:prstGeom>
-          <a:noFill/>
-          <a:ln/>
-        </p:spPr>
-        <p:txBody>
-          <a:bodyPr wrap="square" lIns="0" tIns="0" rIns="0" bIns="0" rtlCol="0" anchor="ctr"/>
-          <a:lstStyle/>
-          <a:p>
-            <a:pPr algn="r" indent="0" marL="0">
-              <a:buNone/>
-            </a:pPr>
-            <a:r>
-              <a:rPr lang="en-US" sz="1000" dirty="0">
-                <a:solidFill>
-                  <a:srgbClr val="5D6D7E"/>
-                </a:solidFill>
-                <a:latin typeface="Arial" pitchFamily="34" charset="0"/>
-                <a:ea typeface="Arial" pitchFamily="34" charset="-122"/>
-                <a:cs typeface="Arial" pitchFamily="34" charset="-120"/>
-              </a:rPr>
               <a:t>13</a:t>
             </a:r>
             <a:endParaRPr lang="en-US" sz="1000" dirty="0"/>
@@ -6939,7 +6561,7 @@
                 <a:ea typeface="Arial" pitchFamily="34" charset="-122"/>
                 <a:cs typeface="Arial" pitchFamily="34" charset="-120"/>
               </a:rPr>
-              <a:t>Conclusiones y recomendaciones</a:t>
+              <a:t>Demostración en vivo</a:t>
             </a:r>
             <a:endParaRPr lang="en-US" sz="3200" dirty="0"/>
           </a:p>
@@ -6947,26 +6569,63 @@
       </p:sp>
       <p:sp>
         <p:nvSpPr>
-          <p:cNvPr id="3" name="Shape 1"/>
+          <p:cNvPr id="3" name="Text 1"/>
+          <p:cNvSpPr txBox="1"/>
+          <p:nvPr/>
+        </p:nvSpPr>
+        <p:spPr>
+          <a:xfrm>
+            <a:off x="548640" y="1051560"/>
+            <a:ext cx="11064240" cy="411480"/>
+          </a:xfrm>
+          <a:prstGeom prst="rect">
+            <a:avLst/>
+          </a:prstGeom>
+          <a:noFill/>
+          <a:ln/>
+        </p:spPr>
+        <p:txBody>
+          <a:bodyPr wrap="square" lIns="0" tIns="0" rIns="0" bIns="0" rtlCol="0" anchor="ctr"/>
+          <a:lstStyle/>
+          <a:p>
+            <a:pPr indent="0" marL="0">
+              <a:buNone/>
+            </a:pPr>
+            <a:r>
+              <a:rPr lang="en-US" sz="1600" dirty="0">
+                <a:solidFill>
+                  <a:srgbClr val="5D6D7E"/>
+                </a:solidFill>
+                <a:latin typeface="Arial" pitchFamily="34" charset="0"/>
+                <a:ea typeface="Arial" pitchFamily="34" charset="-122"/>
+                <a:cs typeface="Arial" pitchFamily="34" charset="-120"/>
+              </a:rPr>
+              <a:t>Sobre la URL de Render, con Postman o Swagger</a:t>
+            </a:r>
+            <a:endParaRPr lang="en-US" sz="1600" dirty="0"/>
+          </a:p>
+        </p:txBody>
+      </p:sp>
+      <p:sp>
+        <p:nvSpPr>
+          <p:cNvPr id="4" name="Shape 2"/>
           <p:cNvSpPr/>
           <p:nvPr/>
         </p:nvSpPr>
         <p:spPr>
           <a:xfrm>
-            <a:off x="548640" y="1371600"/>
-            <a:ext cx="5394960" cy="4754880"/>
-          </a:xfrm>
-          <a:prstGeom prst="roundRect">
-            <a:avLst>
-              <a:gd name="adj" fmla="val 2308"/>
-            </a:avLst>
+            <a:off x="548640" y="1783080"/>
+            <a:ext cx="502920" cy="502920"/>
+          </a:xfrm>
+          <a:prstGeom prst="ellipse">
+            <a:avLst/>
           </a:prstGeom>
           <a:solidFill>
-            <a:srgbClr val="F2F4F7"/>
+            <a:srgbClr val="0B3D91"/>
           </a:solidFill>
           <a:ln w="12700">
             <a:solidFill>
-              <a:srgbClr val="F2F4F7"/>
+              <a:srgbClr val="0B3D91"/>
             </a:solidFill>
             <a:prstDash val="solid"/>
           </a:ln>
@@ -6974,14 +6633,14 @@
       </p:sp>
       <p:sp>
         <p:nvSpPr>
-          <p:cNvPr id="4" name="Text 2"/>
-          <p:cNvSpPr txBox="1"/>
-          <p:nvPr/>
-        </p:nvSpPr>
-        <p:spPr>
-          <a:xfrm>
-            <a:off x="868680" y="1554480"/>
-            <a:ext cx="4754880" cy="457200"/>
+          <p:cNvPr id="5" name="Text 3"/>
+          <p:cNvSpPr txBox="1"/>
+          <p:nvPr/>
+        </p:nvSpPr>
+        <p:spPr>
+          <a:xfrm>
+            <a:off x="548640" y="1783080"/>
+            <a:ext cx="502920" cy="502920"/>
           </a:xfrm>
           <a:prstGeom prst="rect">
             <a:avLst/>
@@ -6993,55 +6652,50 @@
           <a:bodyPr wrap="square" lIns="0" tIns="0" rIns="0" bIns="0" rtlCol="0" anchor="ctr"/>
           <a:lstStyle/>
           <a:p>
+            <a:pPr algn="ctr" indent="0" marL="0">
+              <a:buNone/>
+            </a:pPr>
+            <a:r>
+              <a:rPr lang="en-US" sz="1500" b="1" dirty="0">
+                <a:solidFill>
+                  <a:srgbClr val="FFFFFF"/>
+                </a:solidFill>
+                <a:latin typeface="Arial" pitchFamily="34" charset="0"/>
+                <a:ea typeface="Arial" pitchFamily="34" charset="-122"/>
+                <a:cs typeface="Arial" pitchFamily="34" charset="-120"/>
+              </a:rPr>
+              <a:t>1</a:t>
+            </a:r>
+            <a:endParaRPr lang="en-US" sz="1500" dirty="0"/>
+          </a:p>
+        </p:txBody>
+      </p:sp>
+      <p:sp>
+        <p:nvSpPr>
+          <p:cNvPr id="6" name="Text 4"/>
+          <p:cNvSpPr txBox="1"/>
+          <p:nvPr/>
+        </p:nvSpPr>
+        <p:spPr>
+          <a:xfrm>
+            <a:off x="1280160" y="1783080"/>
+            <a:ext cx="10241280" cy="502920"/>
+          </a:xfrm>
+          <a:prstGeom prst="rect">
+            <a:avLst/>
+          </a:prstGeom>
+          <a:noFill/>
+          <a:ln/>
+        </p:spPr>
+        <p:txBody>
+          <a:bodyPr wrap="square" lIns="0" tIns="0" rIns="0" bIns="0" rtlCol="0" anchor="ctr"/>
+          <a:lstStyle/>
+          <a:p>
             <a:pPr indent="0" marL="0">
               <a:buNone/>
             </a:pPr>
             <a:r>
-              <a:rPr lang="en-US" sz="2000" b="1" dirty="0">
-                <a:solidFill>
-                  <a:srgbClr val="0B3D91"/>
-                </a:solidFill>
-                <a:latin typeface="Arial" pitchFamily="34" charset="0"/>
-                <a:ea typeface="Arial" pitchFamily="34" charset="-122"/>
-                <a:cs typeface="Arial" pitchFamily="34" charset="-120"/>
-              </a:rPr>
-              <a:t>Conclusiones</a:t>
-            </a:r>
-            <a:endParaRPr lang="en-US" sz="2000" dirty="0"/>
-          </a:p>
-        </p:txBody>
-      </p:sp>
-      <p:sp>
-        <p:nvSpPr>
-          <p:cNvPr id="5" name="Text 3"/>
-          <p:cNvSpPr txBox="1"/>
-          <p:nvPr/>
-        </p:nvSpPr>
-        <p:spPr>
-          <a:xfrm>
-            <a:off x="868680" y="2148840"/>
-            <a:ext cx="4846320" cy="3840480"/>
-          </a:xfrm>
-          <a:prstGeom prst="rect">
-            <a:avLst/>
-          </a:prstGeom>
-          <a:noFill/>
-          <a:ln/>
-        </p:spPr>
-        <p:txBody>
-          <a:bodyPr wrap="square" lIns="0" tIns="0" rIns="0" bIns="0" rtlCol="0" anchor="t"/>
-          <a:lstStyle/>
-          <a:p>
-            <a:pPr marL="342900" indent="-342900">
-              <a:spcAft>
-                <a:spcPts val="1200"/>
-              </a:spcAft>
-              <a:buSzPct val="100000"/>
-              <a:buFont typeface="+mj-lt"/>
-              <a:buAutoNum type="arabicPeriod" startAt="1"/>
-            </a:pPr>
-            <a:r>
-              <a:rPr lang="en-US" sz="1500" dirty="0">
+              <a:rPr lang="en-US" sz="1700" dirty="0">
                 <a:solidFill>
                   <a:srgbClr val="1B2631"/>
                 </a:solidFill>
@@ -7049,78 +6703,32 @@
                 <a:ea typeface="Arial" pitchFamily="34" charset="-122"/>
                 <a:cs typeface="Arial" pitchFamily="34" charset="-120"/>
               </a:rPr>
-              <a:t>Los servicios REST en la nube dan información en tiempo real y reutilizable desde cualquier canal.</a:t>
-            </a:r>
-            <a:endParaRPr lang="en-US" sz="1500" dirty="0"/>
-          </a:p>
-          <a:p>
-            <a:pPr marL="342900" indent="-342900">
-              <a:spcAft>
-                <a:spcPts val="1200"/>
-              </a:spcAft>
-              <a:buSzPct val="100000"/>
-              <a:buFont typeface="+mj-lt"/>
-              <a:buAutoNum type="arabicPeriod" startAt="1"/>
-            </a:pPr>
-            <a:r>
-              <a:rPr lang="en-US" sz="1500" dirty="0">
-                <a:solidFill>
-                  <a:srgbClr val="1B2631"/>
-                </a:solidFill>
-                <a:latin typeface="Arial" pitchFamily="34" charset="0"/>
-                <a:ea typeface="Arial" pitchFamily="34" charset="-122"/>
-                <a:cs typeface="Arial" pitchFamily="34" charset="-120"/>
-              </a:rPr>
-              <a:t>BCrypt, JWT y roles corrigen la debilidad del sistema anterior (MD5) y cumplen la Ley 29733.</a:t>
-            </a:r>
-            <a:endParaRPr lang="en-US" sz="1500" dirty="0"/>
-          </a:p>
-          <a:p>
-            <a:pPr marL="342900" indent="-342900">
-              <a:spcAft>
-                <a:spcPts val="1200"/>
-              </a:spcAft>
-              <a:buSzPct val="100000"/>
-              <a:buFont typeface="+mj-lt"/>
-              <a:buAutoNum type="arabicPeriod" startAt="1"/>
-            </a:pPr>
-            <a:r>
-              <a:rPr lang="en-US" sz="1500" dirty="0">
-                <a:solidFill>
-                  <a:srgbClr val="1B2631"/>
-                </a:solidFill>
-                <a:latin typeface="Arial" pitchFamily="34" charset="0"/>
-                <a:ea typeface="Arial" pitchFamily="34" charset="-122"/>
-                <a:cs typeface="Arial" pitchFamily="34" charset="-120"/>
-              </a:rPr>
-              <a:t>Las reglas en el servidor y 42 pruebas eliminan cálculos manuales y la doble asignación.</a:t>
-            </a:r>
-            <a:endParaRPr lang="en-US" sz="1500" dirty="0"/>
-          </a:p>
-        </p:txBody>
-      </p:sp>
-      <p:sp>
-        <p:nvSpPr>
-          <p:cNvPr id="6" name="Shape 4"/>
+              <a:t>Login con admin → token JWT; login con clave errónea → 401</a:t>
+            </a:r>
+            <a:endParaRPr lang="en-US" sz="1700" dirty="0"/>
+          </a:p>
+        </p:txBody>
+      </p:sp>
+      <p:sp>
+        <p:nvSpPr>
+          <p:cNvPr id="7" name="Shape 5"/>
           <p:cNvSpPr/>
           <p:nvPr/>
         </p:nvSpPr>
         <p:spPr>
           <a:xfrm>
-            <a:off x="6263640" y="1371600"/>
-            <a:ext cx="5394960" cy="4754880"/>
-          </a:xfrm>
-          <a:prstGeom prst="roundRect">
-            <a:avLst>
-              <a:gd name="adj" fmla="val 2308"/>
-            </a:avLst>
+            <a:off x="548640" y="2423160"/>
+            <a:ext cx="502920" cy="502920"/>
+          </a:xfrm>
+          <a:prstGeom prst="ellipse">
+            <a:avLst/>
           </a:prstGeom>
           <a:solidFill>
-            <a:srgbClr val="1B2631"/>
+            <a:srgbClr val="0B3D91"/>
           </a:solidFill>
           <a:ln w="12700">
             <a:solidFill>
-              <a:srgbClr val="1B2631"/>
+              <a:srgbClr val="0B3D91"/>
             </a:solidFill>
             <a:prstDash val="solid"/>
           </a:ln>
@@ -7128,14 +6736,14 @@
       </p:sp>
       <p:sp>
         <p:nvSpPr>
-          <p:cNvPr id="7" name="Text 5"/>
-          <p:cNvSpPr txBox="1"/>
-          <p:nvPr/>
-        </p:nvSpPr>
-        <p:spPr>
-          <a:xfrm>
-            <a:off x="6583680" y="1554480"/>
-            <a:ext cx="4754880" cy="457200"/>
+          <p:cNvPr id="8" name="Text 6"/>
+          <p:cNvSpPr txBox="1"/>
+          <p:nvPr/>
+        </p:nvSpPr>
+        <p:spPr>
+          <a:xfrm>
+            <a:off x="548640" y="2423160"/>
+            <a:ext cx="502920" cy="502920"/>
           </a:xfrm>
           <a:prstGeom prst="rect">
             <a:avLst/>
@@ -7147,55 +6755,114 @@
           <a:bodyPr wrap="square" lIns="0" tIns="0" rIns="0" bIns="0" rtlCol="0" anchor="ctr"/>
           <a:lstStyle/>
           <a:p>
+            <a:pPr algn="ctr" indent="0" marL="0">
+              <a:buNone/>
+            </a:pPr>
+            <a:r>
+              <a:rPr lang="en-US" sz="1500" b="1" dirty="0">
+                <a:solidFill>
+                  <a:srgbClr val="FFFFFF"/>
+                </a:solidFill>
+                <a:latin typeface="Arial" pitchFamily="34" charset="0"/>
+                <a:ea typeface="Arial" pitchFamily="34" charset="-122"/>
+                <a:cs typeface="Arial" pitchFamily="34" charset="-120"/>
+              </a:rPr>
+              <a:t>2</a:t>
+            </a:r>
+            <a:endParaRPr lang="en-US" sz="1500" dirty="0"/>
+          </a:p>
+        </p:txBody>
+      </p:sp>
+      <p:sp>
+        <p:nvSpPr>
+          <p:cNvPr id="9" name="Text 7"/>
+          <p:cNvSpPr txBox="1"/>
+          <p:nvPr/>
+        </p:nvSpPr>
+        <p:spPr>
+          <a:xfrm>
+            <a:off x="1280160" y="2423160"/>
+            <a:ext cx="10241280" cy="502920"/>
+          </a:xfrm>
+          <a:prstGeom prst="rect">
+            <a:avLst/>
+          </a:prstGeom>
+          <a:noFill/>
+          <a:ln/>
+        </p:spPr>
+        <p:txBody>
+          <a:bodyPr wrap="square" lIns="0" tIns="0" rIns="0" bIns="0" rtlCol="0" anchor="ctr"/>
+          <a:lstStyle/>
+          <a:p>
             <a:pPr indent="0" marL="0">
               <a:buNone/>
             </a:pPr>
             <a:r>
-              <a:rPr lang="en-US" sz="2000" b="1" dirty="0">
-                <a:solidFill>
-                  <a:srgbClr val="E8A317"/>
-                </a:solidFill>
-                <a:latin typeface="Arial" pitchFamily="34" charset="0"/>
-                <a:ea typeface="Arial" pitchFamily="34" charset="-122"/>
-                <a:cs typeface="Arial" pitchFamily="34" charset="-120"/>
-              </a:rPr>
-              <a:t>Recomendaciones</a:t>
-            </a:r>
-            <a:endParaRPr lang="en-US" sz="2000" dirty="0"/>
-          </a:p>
-        </p:txBody>
-      </p:sp>
-      <p:sp>
-        <p:nvSpPr>
-          <p:cNvPr id="8" name="Text 6"/>
-          <p:cNvSpPr txBox="1"/>
-          <p:nvPr/>
-        </p:nvSpPr>
-        <p:spPr>
-          <a:xfrm>
-            <a:off x="6583680" y="2148840"/>
-            <a:ext cx="4846320" cy="3840480"/>
-          </a:xfrm>
-          <a:prstGeom prst="rect">
-            <a:avLst/>
-          </a:prstGeom>
-          <a:noFill/>
-          <a:ln/>
-        </p:spPr>
-        <p:txBody>
-          <a:bodyPr wrap="square" lIns="0" tIns="0" rIns="0" bIns="0" rtlCol="0" anchor="t"/>
-          <a:lstStyle/>
-          <a:p>
-            <a:pPr marL="342900" indent="-342900">
-              <a:spcAft>
-                <a:spcPts val="1200"/>
-              </a:spcAft>
-              <a:buSzPct val="100000"/>
-              <a:buFont typeface="+mj-lt"/>
-              <a:buAutoNum type="arabicPeriod" startAt="1"/>
-            </a:pPr>
-            <a:r>
-              <a:rPr lang="en-US" sz="1500" dirty="0">
+              <a:rPr lang="en-US" sz="1700" dirty="0">
+                <a:solidFill>
+                  <a:srgbClr val="1B2631"/>
+                </a:solidFill>
+                <a:latin typeface="Arial" pitchFamily="34" charset="0"/>
+                <a:ea typeface="Arial" pitchFamily="34" charset="-122"/>
+                <a:cs typeface="Arial" pitchFamily="34" charset="-120"/>
+              </a:rPr>
+              <a:t>GET de vehículos y POST de un cliente nuevo (201)</a:t>
+            </a:r>
+            <a:endParaRPr lang="en-US" sz="1700" dirty="0"/>
+          </a:p>
+        </p:txBody>
+      </p:sp>
+      <p:sp>
+        <p:nvSpPr>
+          <p:cNvPr id="10" name="Shape 8"/>
+          <p:cNvSpPr/>
+          <p:nvPr/>
+        </p:nvSpPr>
+        <p:spPr>
+          <a:xfrm>
+            <a:off x="548640" y="3063240"/>
+            <a:ext cx="502920" cy="502920"/>
+          </a:xfrm>
+          <a:prstGeom prst="ellipse">
+            <a:avLst/>
+          </a:prstGeom>
+          <a:solidFill>
+            <a:srgbClr val="0B3D91"/>
+          </a:solidFill>
+          <a:ln w="12700">
+            <a:solidFill>
+              <a:srgbClr val="0B3D91"/>
+            </a:solidFill>
+            <a:prstDash val="solid"/>
+          </a:ln>
+        </p:spPr>
+      </p:sp>
+      <p:sp>
+        <p:nvSpPr>
+          <p:cNvPr id="11" name="Text 9"/>
+          <p:cNvSpPr txBox="1"/>
+          <p:nvPr/>
+        </p:nvSpPr>
+        <p:spPr>
+          <a:xfrm>
+            <a:off x="548640" y="3063240"/>
+            <a:ext cx="502920" cy="502920"/>
+          </a:xfrm>
+          <a:prstGeom prst="rect">
+            <a:avLst/>
+          </a:prstGeom>
+          <a:noFill/>
+          <a:ln/>
+        </p:spPr>
+        <p:txBody>
+          <a:bodyPr wrap="square" lIns="0" tIns="0" rIns="0" bIns="0" rtlCol="0" anchor="ctr"/>
+          <a:lstStyle/>
+          <a:p>
+            <a:pPr algn="ctr" indent="0" marL="0">
+              <a:buNone/>
+            </a:pPr>
+            <a:r>
+              <a:rPr lang="en-US" sz="1500" b="1" dirty="0">
                 <a:solidFill>
                   <a:srgbClr val="FFFFFF"/>
                 </a:solidFill>
@@ -7203,21 +6870,102 @@
                 <a:ea typeface="Arial" pitchFamily="34" charset="-122"/>
                 <a:cs typeface="Arial" pitchFamily="34" charset="-120"/>
               </a:rPr>
-              <a:t>Configurar todo por variables de entorno desde el inicio, sin claves en el código.</a:t>
+              <a:t>3</a:t>
             </a:r>
             <a:endParaRPr lang="en-US" sz="1500" dirty="0"/>
           </a:p>
-          <a:p>
-            <a:pPr marL="342900" indent="-342900">
-              <a:spcAft>
-                <a:spcPts val="1200"/>
-              </a:spcAft>
-              <a:buSzPct val="100000"/>
-              <a:buFont typeface="+mj-lt"/>
-              <a:buAutoNum type="arabicPeriod" startAt="1"/>
-            </a:pPr>
-            <a:r>
-              <a:rPr lang="en-US" sz="1500" dirty="0">
+        </p:txBody>
+      </p:sp>
+      <p:sp>
+        <p:nvSpPr>
+          <p:cNvPr id="12" name="Text 10"/>
+          <p:cNvSpPr txBox="1"/>
+          <p:nvPr/>
+        </p:nvSpPr>
+        <p:spPr>
+          <a:xfrm>
+            <a:off x="1280160" y="3063240"/>
+            <a:ext cx="10241280" cy="502920"/>
+          </a:xfrm>
+          <a:prstGeom prst="rect">
+            <a:avLst/>
+          </a:prstGeom>
+          <a:noFill/>
+          <a:ln/>
+        </p:spPr>
+        <p:txBody>
+          <a:bodyPr wrap="square" lIns="0" tIns="0" rIns="0" bIns="0" rtlCol="0" anchor="ctr"/>
+          <a:lstStyle/>
+          <a:p>
+            <a:pPr indent="0" marL="0">
+              <a:buNone/>
+            </a:pPr>
+            <a:r>
+              <a:rPr lang="en-US" sz="1700" dirty="0">
+                <a:solidFill>
+                  <a:srgbClr val="1B2631"/>
+                </a:solidFill>
+                <a:latin typeface="Arial" pitchFamily="34" charset="0"/>
+                <a:ea typeface="Arial" pitchFamily="34" charset="-122"/>
+                <a:cs typeface="Arial" pitchFamily="34" charset="-120"/>
+              </a:rPr>
+              <a:t>PUT del cliente (200) y DELETE (204); GET posterior → 404</a:t>
+            </a:r>
+            <a:endParaRPr lang="en-US" sz="1700" dirty="0"/>
+          </a:p>
+        </p:txBody>
+      </p:sp>
+      <p:sp>
+        <p:nvSpPr>
+          <p:cNvPr id="13" name="Shape 11"/>
+          <p:cNvSpPr/>
+          <p:nvPr/>
+        </p:nvSpPr>
+        <p:spPr>
+          <a:xfrm>
+            <a:off x="548640" y="3703320"/>
+            <a:ext cx="502920" cy="502920"/>
+          </a:xfrm>
+          <a:prstGeom prst="ellipse">
+            <a:avLst/>
+          </a:prstGeom>
+          <a:solidFill>
+            <a:srgbClr val="0B3D91"/>
+          </a:solidFill>
+          <a:ln w="12700">
+            <a:solidFill>
+              <a:srgbClr val="0B3D91"/>
+            </a:solidFill>
+            <a:prstDash val="solid"/>
+          </a:ln>
+        </p:spPr>
+      </p:sp>
+      <p:sp>
+        <p:nvSpPr>
+          <p:cNvPr id="14" name="Text 12"/>
+          <p:cNvSpPr txBox="1"/>
+          <p:nvPr/>
+        </p:nvSpPr>
+        <p:spPr>
+          <a:xfrm>
+            <a:off x="548640" y="3703320"/>
+            <a:ext cx="502920" cy="502920"/>
+          </a:xfrm>
+          <a:prstGeom prst="rect">
+            <a:avLst/>
+          </a:prstGeom>
+          <a:noFill/>
+          <a:ln/>
+        </p:spPr>
+        <p:txBody>
+          <a:bodyPr wrap="square" lIns="0" tIns="0" rIns="0" bIns="0" rtlCol="0" anchor="ctr"/>
+          <a:lstStyle/>
+          <a:p>
+            <a:pPr algn="ctr" indent="0" marL="0">
+              <a:buNone/>
+            </a:pPr>
+            <a:r>
+              <a:rPr lang="en-US" sz="1500" b="1" dirty="0">
                 <a:solidFill>
                   <a:srgbClr val="FFFFFF"/>
                 </a:solidFill>
@@ -7225,21 +6973,102 @@
                 <a:ea typeface="Arial" pitchFamily="34" charset="-122"/>
                 <a:cs typeface="Arial" pitchFamily="34" charset="-120"/>
               </a:rPr>
-              <a:t>Escribir las pruebas de la capa de datos junto con cada entidad.</a:t>
+              <a:t>4</a:t>
             </a:r>
             <a:endParaRPr lang="en-US" sz="1500" dirty="0"/>
           </a:p>
-          <a:p>
-            <a:pPr marL="342900" indent="-342900">
-              <a:spcAft>
-                <a:spcPts val="1200"/>
-              </a:spcAft>
-              <a:buSzPct val="100000"/>
-              <a:buFont typeface="+mj-lt"/>
-              <a:buAutoNum type="arabicPeriod" startAt="1"/>
-            </a:pPr>
-            <a:r>
-              <a:rPr lang="en-US" sz="1500" dirty="0">
+        </p:txBody>
+      </p:sp>
+      <p:sp>
+        <p:nvSpPr>
+          <p:cNvPr id="15" name="Text 13"/>
+          <p:cNvSpPr txBox="1"/>
+          <p:nvPr/>
+        </p:nvSpPr>
+        <p:spPr>
+          <a:xfrm>
+            <a:off x="1280160" y="3703320"/>
+            <a:ext cx="10241280" cy="502920"/>
+          </a:xfrm>
+          <a:prstGeom prst="rect">
+            <a:avLst/>
+          </a:prstGeom>
+          <a:noFill/>
+          <a:ln/>
+        </p:spPr>
+        <p:txBody>
+          <a:bodyPr wrap="square" lIns="0" tIns="0" rIns="0" bIns="0" rtlCol="0" anchor="ctr"/>
+          <a:lstStyle/>
+          <a:p>
+            <a:pPr indent="0" marL="0">
+              <a:buNone/>
+            </a:pPr>
+            <a:r>
+              <a:rPr lang="en-US" sz="1700" dirty="0">
+                <a:solidFill>
+                  <a:srgbClr val="1B2631"/>
+                </a:solidFill>
+                <a:latin typeface="Arial" pitchFamily="34" charset="0"/>
+                <a:ea typeface="Arial" pitchFamily="34" charset="-122"/>
+                <a:cs typeface="Arial" pitchFamily="34" charset="-120"/>
+              </a:rPr>
+              <a:t>POST de contrato: IGV y total calculados; mismo vehículo y fechas → 409</a:t>
+            </a:r>
+            <a:endParaRPr lang="en-US" sz="1700" dirty="0"/>
+          </a:p>
+        </p:txBody>
+      </p:sp>
+      <p:sp>
+        <p:nvSpPr>
+          <p:cNvPr id="16" name="Shape 14"/>
+          <p:cNvSpPr/>
+          <p:nvPr/>
+        </p:nvSpPr>
+        <p:spPr>
+          <a:xfrm>
+            <a:off x="548640" y="4343400"/>
+            <a:ext cx="502920" cy="502920"/>
+          </a:xfrm>
+          <a:prstGeom prst="ellipse">
+            <a:avLst/>
+          </a:prstGeom>
+          <a:solidFill>
+            <a:srgbClr val="0B3D91"/>
+          </a:solidFill>
+          <a:ln w="12700">
+            <a:solidFill>
+              <a:srgbClr val="0B3D91"/>
+            </a:solidFill>
+            <a:prstDash val="solid"/>
+          </a:ln>
+        </p:spPr>
+      </p:sp>
+      <p:sp>
+        <p:nvSpPr>
+          <p:cNvPr id="17" name="Text 15"/>
+          <p:cNvSpPr txBox="1"/>
+          <p:nvPr/>
+        </p:nvSpPr>
+        <p:spPr>
+          <a:xfrm>
+            <a:off x="548640" y="4343400"/>
+            <a:ext cx="502920" cy="502920"/>
+          </a:xfrm>
+          <a:prstGeom prst="rect">
+            <a:avLst/>
+          </a:prstGeom>
+          <a:noFill/>
+          <a:ln/>
+        </p:spPr>
+        <p:txBody>
+          <a:bodyPr wrap="square" lIns="0" tIns="0" rIns="0" bIns="0" rtlCol="0" anchor="ctr"/>
+          <a:lstStyle/>
+          <a:p>
+            <a:pPr algn="ctr" indent="0" marL="0">
+              <a:buNone/>
+            </a:pPr>
+            <a:r>
+              <a:rPr lang="en-US" sz="1500" b="1" dirty="0">
                 <a:solidFill>
                   <a:srgbClr val="FFFFFF"/>
                 </a:solidFill>
@@ -7247,7 +7076,7 @@
                 <a:ea typeface="Arial" pitchFamily="34" charset="-122"/>
                 <a:cs typeface="Arial" pitchFamily="34" charset="-120"/>
               </a:rPr>
-              <a:t>Siguiente etapa: front web o móvil, paginación y alertas de SOAT y revisión técnica.</a:t>
+              <a:t>5</a:t>
             </a:r>
             <a:endParaRPr lang="en-US" sz="1500" dirty="0"/>
           </a:p>
@@ -7255,7 +7084,252 @@
       </p:sp>
       <p:sp>
         <p:nvSpPr>
-          <p:cNvPr id="9" name="Text 7"/>
+          <p:cNvPr id="18" name="Text 16"/>
+          <p:cNvSpPr txBox="1"/>
+          <p:nvPr/>
+        </p:nvSpPr>
+        <p:spPr>
+          <a:xfrm>
+            <a:off x="1280160" y="4343400"/>
+            <a:ext cx="10241280" cy="502920"/>
+          </a:xfrm>
+          <a:prstGeom prst="rect">
+            <a:avLst/>
+          </a:prstGeom>
+          <a:noFill/>
+          <a:ln/>
+        </p:spPr>
+        <p:txBody>
+          <a:bodyPr wrap="square" lIns="0" tIns="0" rIns="0" bIns="0" rtlCol="0" anchor="ctr"/>
+          <a:lstStyle/>
+          <a:p>
+            <a:pPr indent="0" marL="0">
+              <a:buNone/>
+            </a:pPr>
+            <a:r>
+              <a:rPr lang="en-US" sz="1700" dirty="0">
+                <a:solidFill>
+                  <a:srgbClr val="1B2631"/>
+                </a:solidFill>
+                <a:latin typeface="Arial" pitchFamily="34" charset="0"/>
+                <a:ea typeface="Arial" pitchFamily="34" charset="-122"/>
+                <a:cs typeface="Arial" pitchFamily="34" charset="-120"/>
+              </a:rPr>
+              <a:t>DELETE con rol OPERADOR → 403 (solo ADMIN elimina)</a:t>
+            </a:r>
+            <a:endParaRPr lang="en-US" sz="1700" dirty="0"/>
+          </a:p>
+        </p:txBody>
+      </p:sp>
+      <p:sp>
+        <p:nvSpPr>
+          <p:cNvPr id="19" name="Shape 17"/>
+          <p:cNvSpPr/>
+          <p:nvPr/>
+        </p:nvSpPr>
+        <p:spPr>
+          <a:xfrm>
+            <a:off x="548640" y="4983480"/>
+            <a:ext cx="502920" cy="502920"/>
+          </a:xfrm>
+          <a:prstGeom prst="ellipse">
+            <a:avLst/>
+          </a:prstGeom>
+          <a:solidFill>
+            <a:srgbClr val="0B3D91"/>
+          </a:solidFill>
+          <a:ln w="12700">
+            <a:solidFill>
+              <a:srgbClr val="0B3D91"/>
+            </a:solidFill>
+            <a:prstDash val="solid"/>
+          </a:ln>
+        </p:spPr>
+      </p:sp>
+      <p:sp>
+        <p:nvSpPr>
+          <p:cNvPr id="20" name="Text 18"/>
+          <p:cNvSpPr txBox="1"/>
+          <p:nvPr/>
+        </p:nvSpPr>
+        <p:spPr>
+          <a:xfrm>
+            <a:off x="548640" y="4983480"/>
+            <a:ext cx="502920" cy="502920"/>
+          </a:xfrm>
+          <a:prstGeom prst="rect">
+            <a:avLst/>
+          </a:prstGeom>
+          <a:noFill/>
+          <a:ln/>
+        </p:spPr>
+        <p:txBody>
+          <a:bodyPr wrap="square" lIns="0" tIns="0" rIns="0" bIns="0" rtlCol="0" anchor="ctr"/>
+          <a:lstStyle/>
+          <a:p>
+            <a:pPr algn="ctr" indent="0" marL="0">
+              <a:buNone/>
+            </a:pPr>
+            <a:r>
+              <a:rPr lang="en-US" sz="1500" b="1" dirty="0">
+                <a:solidFill>
+                  <a:srgbClr val="FFFFFF"/>
+                </a:solidFill>
+                <a:latin typeface="Arial" pitchFamily="34" charset="0"/>
+                <a:ea typeface="Arial" pitchFamily="34" charset="-122"/>
+                <a:cs typeface="Arial" pitchFamily="34" charset="-120"/>
+              </a:rPr>
+              <a:t>6</a:t>
+            </a:r>
+            <a:endParaRPr lang="en-US" sz="1500" dirty="0"/>
+          </a:p>
+        </p:txBody>
+      </p:sp>
+      <p:sp>
+        <p:nvSpPr>
+          <p:cNvPr id="21" name="Text 19"/>
+          <p:cNvSpPr txBox="1"/>
+          <p:nvPr/>
+        </p:nvSpPr>
+        <p:spPr>
+          <a:xfrm>
+            <a:off x="1280160" y="4983480"/>
+            <a:ext cx="10241280" cy="502920"/>
+          </a:xfrm>
+          <a:prstGeom prst="rect">
+            <a:avLst/>
+          </a:prstGeom>
+          <a:noFill/>
+          <a:ln/>
+        </p:spPr>
+        <p:txBody>
+          <a:bodyPr wrap="square" lIns="0" tIns="0" rIns="0" bIns="0" rtlCol="0" anchor="ctr"/>
+          <a:lstStyle/>
+          <a:p>
+            <a:pPr indent="0" marL="0">
+              <a:buNone/>
+            </a:pPr>
+            <a:r>
+              <a:rPr lang="en-US" sz="1700" dirty="0">
+                <a:solidFill>
+                  <a:srgbClr val="1B2631"/>
+                </a:solidFill>
+                <a:latin typeface="Arial" pitchFamily="34" charset="0"/>
+                <a:ea typeface="Arial" pitchFamily="34" charset="-122"/>
+                <a:cs typeface="Arial" pitchFamily="34" charset="-120"/>
+              </a:rPr>
+              <a:t>Interfaz web: login, panel y registro de contrato desde el navegador</a:t>
+            </a:r>
+            <a:endParaRPr lang="en-US" sz="1700" dirty="0"/>
+          </a:p>
+        </p:txBody>
+      </p:sp>
+      <p:sp>
+        <p:nvSpPr>
+          <p:cNvPr id="22" name="Shape 20"/>
+          <p:cNvSpPr/>
+          <p:nvPr/>
+        </p:nvSpPr>
+        <p:spPr>
+          <a:xfrm>
+            <a:off x="548640" y="5623560"/>
+            <a:ext cx="502920" cy="502920"/>
+          </a:xfrm>
+          <a:prstGeom prst="ellipse">
+            <a:avLst/>
+          </a:prstGeom>
+          <a:solidFill>
+            <a:srgbClr val="0B3D91"/>
+          </a:solidFill>
+          <a:ln w="12700">
+            <a:solidFill>
+              <a:srgbClr val="0B3D91"/>
+            </a:solidFill>
+            <a:prstDash val="solid"/>
+          </a:ln>
+        </p:spPr>
+      </p:sp>
+      <p:sp>
+        <p:nvSpPr>
+          <p:cNvPr id="23" name="Text 21"/>
+          <p:cNvSpPr txBox="1"/>
+          <p:nvPr/>
+        </p:nvSpPr>
+        <p:spPr>
+          <a:xfrm>
+            <a:off x="548640" y="5623560"/>
+            <a:ext cx="502920" cy="502920"/>
+          </a:xfrm>
+          <a:prstGeom prst="rect">
+            <a:avLst/>
+          </a:prstGeom>
+          <a:noFill/>
+          <a:ln/>
+        </p:spPr>
+        <p:txBody>
+          <a:bodyPr wrap="square" lIns="0" tIns="0" rIns="0" bIns="0" rtlCol="0" anchor="ctr"/>
+          <a:lstStyle/>
+          <a:p>
+            <a:pPr algn="ctr" indent="0" marL="0">
+              <a:buNone/>
+            </a:pPr>
+            <a:r>
+              <a:rPr lang="en-US" sz="1500" b="1" dirty="0">
+                <a:solidFill>
+                  <a:srgbClr val="FFFFFF"/>
+                </a:solidFill>
+                <a:latin typeface="Arial" pitchFamily="34" charset="0"/>
+                <a:ea typeface="Arial" pitchFamily="34" charset="-122"/>
+                <a:cs typeface="Arial" pitchFamily="34" charset="-120"/>
+              </a:rPr>
+              <a:t>7</a:t>
+            </a:r>
+            <a:endParaRPr lang="en-US" sz="1500" dirty="0"/>
+          </a:p>
+        </p:txBody>
+      </p:sp>
+      <p:sp>
+        <p:nvSpPr>
+          <p:cNvPr id="24" name="Text 22"/>
+          <p:cNvSpPr txBox="1"/>
+          <p:nvPr/>
+        </p:nvSpPr>
+        <p:spPr>
+          <a:xfrm>
+            <a:off x="1280160" y="5623560"/>
+            <a:ext cx="10241280" cy="502920"/>
+          </a:xfrm>
+          <a:prstGeom prst="rect">
+            <a:avLst/>
+          </a:prstGeom>
+          <a:noFill/>
+          <a:ln/>
+        </p:spPr>
+        <p:txBody>
+          <a:bodyPr wrap="square" lIns="0" tIns="0" rIns="0" bIns="0" rtlCol="0" anchor="ctr"/>
+          <a:lstStyle/>
+          <a:p>
+            <a:pPr indent="0" marL="0">
+              <a:buNone/>
+            </a:pPr>
+            <a:r>
+              <a:rPr lang="en-US" sz="1700" dirty="0">
+                <a:solidFill>
+                  <a:srgbClr val="1B2631"/>
+                </a:solidFill>
+                <a:latin typeface="Arial" pitchFamily="34" charset="0"/>
+                <a:ea typeface="Arial" pitchFamily="34" charset="-122"/>
+                <a:cs typeface="Arial" pitchFamily="34" charset="-120"/>
+              </a:rPr>
+              <a:t>mvn test: 42 pruebas en verde</a:t>
+            </a:r>
+            <a:endParaRPr lang="en-US" sz="1700" dirty="0"/>
+          </a:p>
+        </p:txBody>
+      </p:sp>
+      <p:sp>
+        <p:nvSpPr>
+          <p:cNvPr id="25" name="Text 23"/>
           <p:cNvSpPr txBox="1"/>
           <p:nvPr/>
         </p:nvSpPr>
@@ -7294,7 +7368,7 @@
       </p:sp>
       <p:sp>
         <p:nvSpPr>
-          <p:cNvPr id="10" name="Text 8"/>
+          <p:cNvPr id="26" name="Text 24"/>
           <p:cNvSpPr txBox="1"/>
           <p:nvPr/>
         </p:nvSpPr>
@@ -7342,6 +7416,463 @@
 <file path=ppt/slides/slide15.xml><?xml version="1.0" encoding="utf-8"?>
 <p:sld xmlns:a="http://schemas.openxmlformats.org/drawingml/2006/main" xmlns:r="http://schemas.openxmlformats.org/officeDocument/2006/relationships" xmlns:p="http://schemas.openxmlformats.org/presentationml/2006/main">
   <p:cSld name="Slide 15">
+    <p:bg>
+      <p:bgPr>
+        <a:solidFill>
+          <a:srgbClr val="FFFFFF"/>
+        </a:solidFill>
+      </p:bgPr>
+    </p:bg>
+    <p:spTree>
+      <p:nvGrpSpPr>
+        <p:cNvPr id="1" name=""/>
+        <p:cNvGrpSpPr/>
+        <p:nvPr/>
+      </p:nvGrpSpPr>
+      <p:grpSpPr>
+        <a:xfrm>
+          <a:off x="0" y="0"/>
+          <a:ext cx="0" cy="0"/>
+          <a:chOff x="0" y="0"/>
+          <a:chExt cx="0" cy="0"/>
+        </a:xfrm>
+      </p:grpSpPr>
+      <p:sp>
+        <p:nvSpPr>
+          <p:cNvPr id="2" name="Text 0"/>
+          <p:cNvSpPr txBox="1"/>
+          <p:nvPr/>
+        </p:nvSpPr>
+        <p:spPr>
+          <a:xfrm>
+            <a:off x="548640" y="365760"/>
+            <a:ext cx="11064240" cy="731520"/>
+          </a:xfrm>
+          <a:prstGeom prst="rect">
+            <a:avLst/>
+          </a:prstGeom>
+          <a:noFill/>
+          <a:ln/>
+        </p:spPr>
+        <p:txBody>
+          <a:bodyPr wrap="square" lIns="0" tIns="0" rIns="0" bIns="0" rtlCol="0" anchor="ctr"/>
+          <a:lstStyle/>
+          <a:p>
+            <a:pPr indent="0" marL="0">
+              <a:buNone/>
+            </a:pPr>
+            <a:r>
+              <a:rPr lang="en-US" sz="3200" b="1" dirty="0">
+                <a:solidFill>
+                  <a:srgbClr val="1B2631"/>
+                </a:solidFill>
+                <a:latin typeface="Arial" pitchFamily="34" charset="0"/>
+                <a:ea typeface="Arial" pitchFamily="34" charset="-122"/>
+                <a:cs typeface="Arial" pitchFamily="34" charset="-120"/>
+              </a:rPr>
+              <a:t>Conclusiones y recomendaciones</a:t>
+            </a:r>
+            <a:endParaRPr lang="en-US" sz="3200" dirty="0"/>
+          </a:p>
+        </p:txBody>
+      </p:sp>
+      <p:sp>
+        <p:nvSpPr>
+          <p:cNvPr id="3" name="Shape 1"/>
+          <p:cNvSpPr/>
+          <p:nvPr/>
+        </p:nvSpPr>
+        <p:spPr>
+          <a:xfrm>
+            <a:off x="548640" y="1371600"/>
+            <a:ext cx="5394960" cy="4754880"/>
+          </a:xfrm>
+          <a:prstGeom prst="roundRect">
+            <a:avLst>
+              <a:gd name="adj" fmla="val 2308"/>
+            </a:avLst>
+          </a:prstGeom>
+          <a:solidFill>
+            <a:srgbClr val="F2F4F7"/>
+          </a:solidFill>
+          <a:ln w="12700">
+            <a:solidFill>
+              <a:srgbClr val="F2F4F7"/>
+            </a:solidFill>
+            <a:prstDash val="solid"/>
+          </a:ln>
+        </p:spPr>
+      </p:sp>
+      <p:sp>
+        <p:nvSpPr>
+          <p:cNvPr id="4" name="Text 2"/>
+          <p:cNvSpPr txBox="1"/>
+          <p:nvPr/>
+        </p:nvSpPr>
+        <p:spPr>
+          <a:xfrm>
+            <a:off x="868680" y="1554480"/>
+            <a:ext cx="4754880" cy="457200"/>
+          </a:xfrm>
+          <a:prstGeom prst="rect">
+            <a:avLst/>
+          </a:prstGeom>
+          <a:noFill/>
+          <a:ln/>
+        </p:spPr>
+        <p:txBody>
+          <a:bodyPr wrap="square" lIns="0" tIns="0" rIns="0" bIns="0" rtlCol="0" anchor="ctr"/>
+          <a:lstStyle/>
+          <a:p>
+            <a:pPr indent="0" marL="0">
+              <a:buNone/>
+            </a:pPr>
+            <a:r>
+              <a:rPr lang="en-US" sz="2000" b="1" dirty="0">
+                <a:solidFill>
+                  <a:srgbClr val="0B3D91"/>
+                </a:solidFill>
+                <a:latin typeface="Arial" pitchFamily="34" charset="0"/>
+                <a:ea typeface="Arial" pitchFamily="34" charset="-122"/>
+                <a:cs typeface="Arial" pitchFamily="34" charset="-120"/>
+              </a:rPr>
+              <a:t>Conclusiones</a:t>
+            </a:r>
+            <a:endParaRPr lang="en-US" sz="2000" dirty="0"/>
+          </a:p>
+        </p:txBody>
+      </p:sp>
+      <p:sp>
+        <p:nvSpPr>
+          <p:cNvPr id="5" name="Text 3"/>
+          <p:cNvSpPr txBox="1"/>
+          <p:nvPr/>
+        </p:nvSpPr>
+        <p:spPr>
+          <a:xfrm>
+            <a:off x="868680" y="2148840"/>
+            <a:ext cx="4846320" cy="3840480"/>
+          </a:xfrm>
+          <a:prstGeom prst="rect">
+            <a:avLst/>
+          </a:prstGeom>
+          <a:noFill/>
+          <a:ln/>
+        </p:spPr>
+        <p:txBody>
+          <a:bodyPr wrap="square" lIns="0" tIns="0" rIns="0" bIns="0" rtlCol="0" anchor="t"/>
+          <a:lstStyle/>
+          <a:p>
+            <a:pPr marL="342900" indent="-342900">
+              <a:spcAft>
+                <a:spcPts val="1200"/>
+              </a:spcAft>
+              <a:buSzPct val="100000"/>
+              <a:buFont typeface="+mj-lt"/>
+              <a:buAutoNum type="arabicPeriod" startAt="1"/>
+            </a:pPr>
+            <a:r>
+              <a:rPr lang="en-US" sz="1500" dirty="0">
+                <a:solidFill>
+                  <a:srgbClr val="1B2631"/>
+                </a:solidFill>
+                <a:latin typeface="Arial" pitchFamily="34" charset="0"/>
+                <a:ea typeface="Arial" pitchFamily="34" charset="-122"/>
+                <a:cs typeface="Arial" pitchFamily="34" charset="-120"/>
+              </a:rPr>
+              <a:t>Los servicios REST en la nube dan información en tiempo real y reutilizable desde cualquier canal.</a:t>
+            </a:r>
+            <a:endParaRPr lang="en-US" sz="1500" dirty="0"/>
+          </a:p>
+          <a:p>
+            <a:pPr marL="342900" indent="-342900">
+              <a:spcAft>
+                <a:spcPts val="1200"/>
+              </a:spcAft>
+              <a:buSzPct val="100000"/>
+              <a:buFont typeface="+mj-lt"/>
+              <a:buAutoNum type="arabicPeriod" startAt="1"/>
+            </a:pPr>
+            <a:r>
+              <a:rPr lang="en-US" sz="1500" dirty="0">
+                <a:solidFill>
+                  <a:srgbClr val="1B2631"/>
+                </a:solidFill>
+                <a:latin typeface="Arial" pitchFamily="34" charset="0"/>
+                <a:ea typeface="Arial" pitchFamily="34" charset="-122"/>
+                <a:cs typeface="Arial" pitchFamily="34" charset="-120"/>
+              </a:rPr>
+              <a:t>BCrypt, JWT y roles corrigen la debilidad del sistema anterior (MD5) y cumplen la Ley 29733.</a:t>
+            </a:r>
+            <a:endParaRPr lang="en-US" sz="1500" dirty="0"/>
+          </a:p>
+          <a:p>
+            <a:pPr marL="342900" indent="-342900">
+              <a:spcAft>
+                <a:spcPts val="1200"/>
+              </a:spcAft>
+              <a:buSzPct val="100000"/>
+              <a:buFont typeface="+mj-lt"/>
+              <a:buAutoNum type="arabicPeriod" startAt="1"/>
+            </a:pPr>
+            <a:r>
+              <a:rPr lang="en-US" sz="1500" dirty="0">
+                <a:solidFill>
+                  <a:srgbClr val="1B2631"/>
+                </a:solidFill>
+                <a:latin typeface="Arial" pitchFamily="34" charset="0"/>
+                <a:ea typeface="Arial" pitchFamily="34" charset="-122"/>
+                <a:cs typeface="Arial" pitchFamily="34" charset="-120"/>
+              </a:rPr>
+              <a:t>Las reglas en el servidor y 42 pruebas eliminan cálculos manuales y la doble asignación.</a:t>
+            </a:r>
+            <a:endParaRPr lang="en-US" sz="1500" dirty="0"/>
+          </a:p>
+        </p:txBody>
+      </p:sp>
+      <p:sp>
+        <p:nvSpPr>
+          <p:cNvPr id="6" name="Shape 4"/>
+          <p:cNvSpPr/>
+          <p:nvPr/>
+        </p:nvSpPr>
+        <p:spPr>
+          <a:xfrm>
+            <a:off x="6263640" y="1371600"/>
+            <a:ext cx="5394960" cy="4754880"/>
+          </a:xfrm>
+          <a:prstGeom prst="roundRect">
+            <a:avLst>
+              <a:gd name="adj" fmla="val 2308"/>
+            </a:avLst>
+          </a:prstGeom>
+          <a:solidFill>
+            <a:srgbClr val="1B2631"/>
+          </a:solidFill>
+          <a:ln w="12700">
+            <a:solidFill>
+              <a:srgbClr val="1B2631"/>
+            </a:solidFill>
+            <a:prstDash val="solid"/>
+          </a:ln>
+        </p:spPr>
+      </p:sp>
+      <p:sp>
+        <p:nvSpPr>
+          <p:cNvPr id="7" name="Text 5"/>
+          <p:cNvSpPr txBox="1"/>
+          <p:nvPr/>
+        </p:nvSpPr>
+        <p:spPr>
+          <a:xfrm>
+            <a:off x="6583680" y="1554480"/>
+            <a:ext cx="4754880" cy="457200"/>
+          </a:xfrm>
+          <a:prstGeom prst="rect">
+            <a:avLst/>
+          </a:prstGeom>
+          <a:noFill/>
+          <a:ln/>
+        </p:spPr>
+        <p:txBody>
+          <a:bodyPr wrap="square" lIns="0" tIns="0" rIns="0" bIns="0" rtlCol="0" anchor="ctr"/>
+          <a:lstStyle/>
+          <a:p>
+            <a:pPr indent="0" marL="0">
+              <a:buNone/>
+            </a:pPr>
+            <a:r>
+              <a:rPr lang="en-US" sz="2000" b="1" dirty="0">
+                <a:solidFill>
+                  <a:srgbClr val="E8A317"/>
+                </a:solidFill>
+                <a:latin typeface="Arial" pitchFamily="34" charset="0"/>
+                <a:ea typeface="Arial" pitchFamily="34" charset="-122"/>
+                <a:cs typeface="Arial" pitchFamily="34" charset="-120"/>
+              </a:rPr>
+              <a:t>Recomendaciones</a:t>
+            </a:r>
+            <a:endParaRPr lang="en-US" sz="2000" dirty="0"/>
+          </a:p>
+        </p:txBody>
+      </p:sp>
+      <p:sp>
+        <p:nvSpPr>
+          <p:cNvPr id="8" name="Text 6"/>
+          <p:cNvSpPr txBox="1"/>
+          <p:nvPr/>
+        </p:nvSpPr>
+        <p:spPr>
+          <a:xfrm>
+            <a:off x="6583680" y="2148840"/>
+            <a:ext cx="4846320" cy="3840480"/>
+          </a:xfrm>
+          <a:prstGeom prst="rect">
+            <a:avLst/>
+          </a:prstGeom>
+          <a:noFill/>
+          <a:ln/>
+        </p:spPr>
+        <p:txBody>
+          <a:bodyPr wrap="square" lIns="0" tIns="0" rIns="0" bIns="0" rtlCol="0" anchor="t"/>
+          <a:lstStyle/>
+          <a:p>
+            <a:pPr marL="342900" indent="-342900">
+              <a:spcAft>
+                <a:spcPts val="1200"/>
+              </a:spcAft>
+              <a:buSzPct val="100000"/>
+              <a:buFont typeface="+mj-lt"/>
+              <a:buAutoNum type="arabicPeriod" startAt="1"/>
+            </a:pPr>
+            <a:r>
+              <a:rPr lang="en-US" sz="1500" dirty="0">
+                <a:solidFill>
+                  <a:srgbClr val="FFFFFF"/>
+                </a:solidFill>
+                <a:latin typeface="Arial" pitchFamily="34" charset="0"/>
+                <a:ea typeface="Arial" pitchFamily="34" charset="-122"/>
+                <a:cs typeface="Arial" pitchFamily="34" charset="-120"/>
+              </a:rPr>
+              <a:t>Configurar todo por variables de entorno desde el inicio, sin claves en el código.</a:t>
+            </a:r>
+            <a:endParaRPr lang="en-US" sz="1500" dirty="0"/>
+          </a:p>
+          <a:p>
+            <a:pPr marL="342900" indent="-342900">
+              <a:spcAft>
+                <a:spcPts val="1200"/>
+              </a:spcAft>
+              <a:buSzPct val="100000"/>
+              <a:buFont typeface="+mj-lt"/>
+              <a:buAutoNum type="arabicPeriod" startAt="1"/>
+            </a:pPr>
+            <a:r>
+              <a:rPr lang="en-US" sz="1500" dirty="0">
+                <a:solidFill>
+                  <a:srgbClr val="FFFFFF"/>
+                </a:solidFill>
+                <a:latin typeface="Arial" pitchFamily="34" charset="0"/>
+                <a:ea typeface="Arial" pitchFamily="34" charset="-122"/>
+                <a:cs typeface="Arial" pitchFamily="34" charset="-120"/>
+              </a:rPr>
+              <a:t>Escribir las pruebas de la capa de datos junto con cada entidad.</a:t>
+            </a:r>
+            <a:endParaRPr lang="en-US" sz="1500" dirty="0"/>
+          </a:p>
+          <a:p>
+            <a:pPr marL="342900" indent="-342900">
+              <a:spcAft>
+                <a:spcPts val="1200"/>
+              </a:spcAft>
+              <a:buSzPct val="100000"/>
+              <a:buFont typeface="+mj-lt"/>
+              <a:buAutoNum type="arabicPeriod" startAt="1"/>
+            </a:pPr>
+            <a:r>
+              <a:rPr lang="en-US" sz="1500" dirty="0">
+                <a:solidFill>
+                  <a:srgbClr val="FFFFFF"/>
+                </a:solidFill>
+                <a:latin typeface="Arial" pitchFamily="34" charset="0"/>
+                <a:ea typeface="Arial" pitchFamily="34" charset="-122"/>
+                <a:cs typeface="Arial" pitchFamily="34" charset="-120"/>
+              </a:rPr>
+              <a:t>Siguiente etapa: app móvil para conductores, paginación y alertas de SOAT por correo.</a:t>
+            </a:r>
+            <a:endParaRPr lang="en-US" sz="1500" dirty="0"/>
+          </a:p>
+        </p:txBody>
+      </p:sp>
+      <p:sp>
+        <p:nvSpPr>
+          <p:cNvPr id="9" name="Text 7"/>
+          <p:cNvSpPr txBox="1"/>
+          <p:nvPr/>
+        </p:nvSpPr>
+        <p:spPr>
+          <a:xfrm>
+            <a:off x="548640" y="6400800"/>
+            <a:ext cx="5486400" cy="274320"/>
+          </a:xfrm>
+          <a:prstGeom prst="rect">
+            <a:avLst/>
+          </a:prstGeom>
+          <a:noFill/>
+          <a:ln/>
+        </p:spPr>
+        <p:txBody>
+          <a:bodyPr wrap="square" lIns="0" tIns="0" rIns="0" bIns="0" rtlCol="0" anchor="ctr"/>
+          <a:lstStyle/>
+          <a:p>
+            <a:pPr indent="0" marL="0">
+              <a:buNone/>
+            </a:pPr>
+            <a:r>
+              <a:rPr lang="en-US" sz="1000" dirty="0">
+                <a:solidFill>
+                  <a:srgbClr val="5D6D7E"/>
+                </a:solidFill>
+                <a:latin typeface="Arial" pitchFamily="34" charset="0"/>
+                <a:ea typeface="Arial" pitchFamily="34" charset="-122"/>
+                <a:cs typeface="Arial" pitchFamily="34" charset="-120"/>
+              </a:rPr>
+              <a:t>CH&amp;D Rental Pro · DSWII · Grupo 10</a:t>
+            </a:r>
+            <a:endParaRPr lang="en-US" sz="1000" dirty="0"/>
+          </a:p>
+        </p:txBody>
+      </p:sp>
+      <p:sp>
+        <p:nvSpPr>
+          <p:cNvPr id="10" name="Text 8"/>
+          <p:cNvSpPr txBox="1"/>
+          <p:nvPr/>
+        </p:nvSpPr>
+        <p:spPr>
+          <a:xfrm>
+            <a:off x="11155680" y="6400800"/>
+            <a:ext cx="457200" cy="274320"/>
+          </a:xfrm>
+          <a:prstGeom prst="rect">
+            <a:avLst/>
+          </a:prstGeom>
+          <a:noFill/>
+          <a:ln/>
+        </p:spPr>
+        <p:txBody>
+          <a:bodyPr wrap="square" lIns="0" tIns="0" rIns="0" bIns="0" rtlCol="0" anchor="ctr"/>
+          <a:lstStyle/>
+          <a:p>
+            <a:pPr algn="r" indent="0" marL="0">
+              <a:buNone/>
+            </a:pPr>
+            <a:r>
+              <a:rPr lang="en-US" sz="1000" dirty="0">
+                <a:solidFill>
+                  <a:srgbClr val="5D6D7E"/>
+                </a:solidFill>
+                <a:latin typeface="Arial" pitchFamily="34" charset="0"/>
+                <a:ea typeface="Arial" pitchFamily="34" charset="-122"/>
+                <a:cs typeface="Arial" pitchFamily="34" charset="-120"/>
+              </a:rPr>
+              <a:t>15</a:t>
+            </a:r>
+            <a:endParaRPr lang="en-US" sz="1000" dirty="0"/>
+          </a:p>
+        </p:txBody>
+      </p:sp>
+    </p:spTree>
+  </p:cSld>
+  <p:clrMapOvr>
+    <a:masterClrMapping/>
+  </p:clrMapOvr>
+</p:sld>
+</file>
+
+<file path=ppt/slides/slide16.xml><?xml version="1.0" encoding="utf-8"?>
+<p:sld xmlns:a="http://schemas.openxmlformats.org/drawingml/2006/main" xmlns:r="http://schemas.openxmlformats.org/officeDocument/2006/relationships" xmlns:p="http://schemas.openxmlformats.org/presentationml/2006/main">
+  <p:cSld name="Slide 16">
     <p:bg>
       <p:bgPr>
         <a:solidFill>
@@ -7595,7 +8126,7 @@
                 <a:ea typeface="Arial" pitchFamily="34" charset="-122"/>
                 <a:cs typeface="Arial" pitchFamily="34" charset="-120"/>
               </a:rPr>
-              <a:t>15</a:t>
+              <a:t>16</a:t>
             </a:r>
             <a:endParaRPr lang="en-US" sz="1000" dirty="0"/>
           </a:p>

</xml_diff>